<commit_message>
Update PowerPoint presentation deck to light, beautiful aesthetic design
</commit_message>
<xml_diff>
--- a/AgriVision_AI_SIH2026_Presentation.pptx
+++ b/AgriVision_AI_SIH2026_Presentation.pptx
@@ -3112,7 +3112,7 @@
             <a:avLst/>
           </a:prstGeom>
           <a:solidFill>
-            <a:srgbClr val="0B1426"/>
+            <a:srgbClr val="F8FAFC"/>
           </a:solidFill>
           <a:ln>
             <a:noFill/>
@@ -3142,130 +3142,23 @@
       </p:sp>
       <p:sp>
         <p:nvSpPr>
-          <p:cNvPr id="3" name="TextBox 2"/>
-          <p:cNvSpPr txBox="1"/>
-          <p:nvPr/>
-        </p:nvSpPr>
-        <p:spPr>
-          <a:xfrm>
-            <a:off x="731520" y="457200"/>
-            <a:ext cx="10698480" cy="365760"/>
-          </a:xfrm>
-          <a:prstGeom prst="rect">
-            <a:avLst/>
-          </a:prstGeom>
-          <a:noFill/>
-        </p:spPr>
-        <p:txBody>
-          <a:bodyPr wrap="none">
-            <a:spAutoFit/>
-          </a:bodyPr>
-          <a:lstStyle/>
-          <a:p>
-            <a:pPr>
-              <a:defRPr sz="1100" b="1">
-                <a:solidFill>
-                  <a:srgbClr val="10B981"/>
-                </a:solidFill>
-              </a:defRPr>
-            </a:pPr>
-            <a:r>
-              <a:t>SLIDE 1 | PRODUCTION PLATFORM DEPLOYED</a:t>
-            </a:r>
-          </a:p>
-        </p:txBody>
-      </p:sp>
-      <p:sp>
-        <p:nvSpPr>
-          <p:cNvPr id="4" name="TextBox 3"/>
-          <p:cNvSpPr txBox="1"/>
-          <p:nvPr/>
-        </p:nvSpPr>
-        <p:spPr>
-          <a:xfrm>
-            <a:off x="731520" y="777240"/>
-            <a:ext cx="10698480" cy="731520"/>
-          </a:xfrm>
-          <a:prstGeom prst="rect">
-            <a:avLst/>
-          </a:prstGeom>
-          <a:noFill/>
-        </p:spPr>
-        <p:txBody>
-          <a:bodyPr wrap="none">
-            <a:spAutoFit/>
-          </a:bodyPr>
-          <a:lstStyle/>
-          <a:p>
-            <a:pPr>
-              <a:defRPr sz="2600" b="1">
-                <a:solidFill>
-                  <a:srgbClr val="FFFFFF"/>
-                </a:solidFill>
-              </a:defRPr>
-            </a:pPr>
-            <a:r>
-              <a:t>AgriVision AI (Production Platform)</a:t>
-            </a:r>
-          </a:p>
-        </p:txBody>
-      </p:sp>
-      <p:sp>
-        <p:nvSpPr>
-          <p:cNvPr id="5" name="TextBox 4"/>
-          <p:cNvSpPr txBox="1"/>
-          <p:nvPr/>
-        </p:nvSpPr>
-        <p:spPr>
-          <a:xfrm>
-            <a:off x="731520" y="1371600"/>
-            <a:ext cx="10698480" cy="457200"/>
-          </a:xfrm>
-          <a:prstGeom prst="rect">
-            <a:avLst/>
-          </a:prstGeom>
-          <a:noFill/>
-        </p:spPr>
-        <p:txBody>
-          <a:bodyPr wrap="none">
-            <a:spAutoFit/>
-          </a:bodyPr>
-          <a:lstStyle/>
-          <a:p>
-            <a:pPr>
-              <a:defRPr sz="1500" b="1">
-                <a:solidFill>
-                  <a:srgbClr val="34D399"/>
-                </a:solidFill>
-              </a:defRPr>
-            </a:pPr>
-            <a:r>
-              <a:t>Unified AI Agri-Vision &amp; Veterinary Clinical Diagnostic System</a:t>
-            </a:r>
-          </a:p>
-        </p:txBody>
-      </p:sp>
-      <p:sp>
-        <p:nvSpPr>
-          <p:cNvPr id="6" name="Rounded Rectangle 5"/>
+          <p:cNvPr id="3" name="Rectangle 2"/>
           <p:cNvSpPr/>
           <p:nvPr/>
         </p:nvSpPr>
         <p:spPr>
           <a:xfrm>
-            <a:off x="731520" y="2011680"/>
-            <a:ext cx="5303520" cy="4297680"/>
-          </a:xfrm>
-          <a:prstGeom prst="roundRect">
+            <a:off x="731520" y="365760"/>
+            <a:ext cx="10728655" cy="54864"/>
+          </a:xfrm>
+          <a:prstGeom prst="rect">
             <a:avLst/>
           </a:prstGeom>
           <a:solidFill>
-            <a:srgbClr val="111C34"/>
+            <a:srgbClr val="047857"/>
           </a:solidFill>
-          <a:ln w="19050">
-            <a:solidFill>
-              <a:srgbClr val="10B981"/>
-            </a:solidFill>
+          <a:ln>
+            <a:noFill/>
           </a:ln>
         </p:spPr>
         <p:style>
@@ -3292,14 +3185,164 @@
       </p:sp>
       <p:sp>
         <p:nvSpPr>
-          <p:cNvPr id="7" name="TextBox 6"/>
+          <p:cNvPr id="4" name="TextBox 3"/>
           <p:cNvSpPr txBox="1"/>
           <p:nvPr/>
         </p:nvSpPr>
         <p:spPr>
           <a:xfrm>
+            <a:off x="731520" y="502920"/>
+            <a:ext cx="10698480" cy="320040"/>
+          </a:xfrm>
+          <a:prstGeom prst="rect">
+            <a:avLst/>
+          </a:prstGeom>
+          <a:noFill/>
+        </p:spPr>
+        <p:txBody>
+          <a:bodyPr wrap="none">
+            <a:spAutoFit/>
+          </a:bodyPr>
+          <a:lstStyle/>
+          <a:p>
+            <a:pPr>
+              <a:defRPr sz="1100" b="1">
+                <a:solidFill>
+                  <a:srgbClr val="047857"/>
+                </a:solidFill>
+              </a:defRPr>
+            </a:pPr>
+            <a:r>
+              <a:t>SLIDE 1  |  PRODUCTION PLATFORM DEPLOYED</a:t>
+            </a:r>
+          </a:p>
+        </p:txBody>
+      </p:sp>
+      <p:sp>
+        <p:nvSpPr>
+          <p:cNvPr id="5" name="TextBox 4"/>
+          <p:cNvSpPr txBox="1"/>
+          <p:nvPr/>
+        </p:nvSpPr>
+        <p:spPr>
+          <a:xfrm>
+            <a:off x="731520" y="822960"/>
+            <a:ext cx="10698480" cy="685800"/>
+          </a:xfrm>
+          <a:prstGeom prst="rect">
+            <a:avLst/>
+          </a:prstGeom>
+          <a:noFill/>
+        </p:spPr>
+        <p:txBody>
+          <a:bodyPr wrap="none">
+            <a:spAutoFit/>
+          </a:bodyPr>
+          <a:lstStyle/>
+          <a:p>
+            <a:pPr>
+              <a:defRPr sz="2600" b="1">
+                <a:solidFill>
+                  <a:srgbClr val="065F46"/>
+                </a:solidFill>
+              </a:defRPr>
+            </a:pPr>
+            <a:r>
+              <a:t>AgriVision AI (Production Platform)</a:t>
+            </a:r>
+          </a:p>
+        </p:txBody>
+      </p:sp>
+      <p:sp>
+        <p:nvSpPr>
+          <p:cNvPr id="6" name="TextBox 5"/>
+          <p:cNvSpPr txBox="1"/>
+          <p:nvPr/>
+        </p:nvSpPr>
+        <p:spPr>
+          <a:xfrm>
+            <a:off x="731520" y="1463040"/>
+            <a:ext cx="10698480" cy="411480"/>
+          </a:xfrm>
+          <a:prstGeom prst="rect">
+            <a:avLst/>
+          </a:prstGeom>
+          <a:noFill/>
+        </p:spPr>
+        <p:txBody>
+          <a:bodyPr wrap="none">
+            <a:spAutoFit/>
+          </a:bodyPr>
+          <a:lstStyle/>
+          <a:p>
+            <a:pPr>
+              <a:defRPr sz="1500" b="1">
+                <a:solidFill>
+                  <a:srgbClr val="0D9488"/>
+                </a:solidFill>
+              </a:defRPr>
+            </a:pPr>
+            <a:r>
+              <a:t>Unified AI Agri-Vision &amp; Veterinary Clinical Diagnostic System</a:t>
+            </a:r>
+          </a:p>
+        </p:txBody>
+      </p:sp>
+      <p:sp>
+        <p:nvSpPr>
+          <p:cNvPr id="7" name="Rounded Rectangle 6"/>
+          <p:cNvSpPr/>
+          <p:nvPr/>
+        </p:nvSpPr>
+        <p:spPr>
+          <a:xfrm>
+            <a:off x="731520" y="2011680"/>
+            <a:ext cx="5303520" cy="4206240"/>
+          </a:xfrm>
+          <a:prstGeom prst="roundRect">
+            <a:avLst/>
+          </a:prstGeom>
+          <a:solidFill>
+            <a:srgbClr val="F0FDF4"/>
+          </a:solidFill>
+          <a:ln w="19050">
+            <a:solidFill>
+              <a:srgbClr val="A7F3D0"/>
+            </a:solidFill>
+          </a:ln>
+        </p:spPr>
+        <p:style>
+          <a:lnRef idx="1">
+            <a:schemeClr val="accent1"/>
+          </a:lnRef>
+          <a:fillRef idx="3">
+            <a:schemeClr val="accent1"/>
+          </a:fillRef>
+          <a:effectRef idx="2">
+            <a:schemeClr val="accent1"/>
+          </a:effectRef>
+          <a:fontRef idx="minor">
+            <a:schemeClr val="lt1"/>
+          </a:fontRef>
+        </p:style>
+        <p:txBody>
+          <a:bodyPr rtlCol="0" anchor="ctr"/>
+          <a:lstStyle/>
+          <a:p>
+            <a:pPr algn="ctr"/>
+          </a:p>
+        </p:txBody>
+      </p:sp>
+      <p:sp>
+        <p:nvSpPr>
+          <p:cNvPr id="8" name="TextBox 7"/>
+          <p:cNvSpPr txBox="1"/>
+          <p:nvPr/>
+        </p:nvSpPr>
+        <p:spPr>
+          <a:xfrm>
             <a:off x="914400" y="2194560"/>
-            <a:ext cx="4937760" cy="3931920"/>
+            <a:ext cx="4937760" cy="3840480"/>
           </a:xfrm>
           <a:prstGeom prst="rect">
             <a:avLst/>
@@ -3314,97 +3357,97 @@
           <a:p>
             <a:pPr>
               <a:lnSpc>
-                <a:spcPct val="120000"/>
+                <a:spcPct val="125000"/>
               </a:lnSpc>
               <a:spcAft>
                 <a:spcPts val="1400"/>
               </a:spcAft>
               <a:defRPr sz="1400">
                 <a:solidFill>
-                  <a:srgbClr val="F3F4F6"/>
+                  <a:srgbClr val="1E293B"/>
                 </a:solidFill>
               </a:defRPr>
             </a:pPr>
             <a:r>
-              <a:t>• Smart India Hackathon 2026 Candidate - IIT Jodhpur</a:t>
+              <a:t>✔  Smart India Hackathon 2026 Candidate - IIT Jodhpur</a:t>
             </a:r>
           </a:p>
           <a:p>
             <a:pPr>
               <a:lnSpc>
-                <a:spcPct val="120000"/>
+                <a:spcPct val="125000"/>
               </a:lnSpc>
               <a:spcAft>
                 <a:spcPts val="1400"/>
               </a:spcAft>
               <a:defRPr sz="1400">
                 <a:solidFill>
-                  <a:srgbClr val="F3F4F6"/>
+                  <a:srgbClr val="1E293B"/>
                 </a:solidFill>
               </a:defRPr>
             </a:pPr>
             <a:r>
-              <a:t>• Problem Statement 1: Software Domain</a:t>
+              <a:t>✔  Problem Statement 1: Software Domain</a:t>
             </a:r>
           </a:p>
           <a:p>
             <a:pPr>
               <a:lnSpc>
-                <a:spcPct val="120000"/>
+                <a:spcPct val="125000"/>
               </a:lnSpc>
               <a:spcAft>
                 <a:spcPts val="1400"/>
               </a:spcAft>
               <a:defRPr sz="1400">
                 <a:solidFill>
-                  <a:srgbClr val="F3F4F6"/>
+                  <a:srgbClr val="1E293B"/>
                 </a:solidFill>
               </a:defRPr>
             </a:pPr>
             <a:r>
-              <a:t>• Lead Presenter: Assistant Nursing Superintendent (AIIMS Jodhpur) &amp; MMT Scholar (IIT Jodhpur)</a:t>
+              <a:t>✔  Lead Presenter: Assistant Nursing Superintendent (AIIMS Jodhpur) &amp; MMT Scholar (IIT Jodhpur)</a:t>
             </a:r>
           </a:p>
           <a:p>
             <a:pPr>
               <a:lnSpc>
-                <a:spcPct val="120000"/>
+                <a:spcPct val="125000"/>
               </a:lnSpc>
               <a:spcAft>
                 <a:spcPts val="1400"/>
               </a:spcAft>
               <a:defRPr sz="1400">
                 <a:solidFill>
-                  <a:srgbClr val="F3F4F6"/>
+                  <a:srgbClr val="1E293B"/>
                 </a:solidFill>
               </a:defRPr>
             </a:pPr>
             <a:r>
-              <a:t>• Live Product Status: Fully Deployed Working Product on Vercel &amp; GitHub</a:t>
-            </a:r>
-          </a:p>
-        </p:txBody>
-      </p:sp>
-      <p:sp>
-        <p:nvSpPr>
-          <p:cNvPr id="8" name="Rounded Rectangle 7"/>
+              <a:t>✔  Live Product Status: Fully Deployed Working Product on Vercel &amp; GitHub</a:t>
+            </a:r>
+          </a:p>
+        </p:txBody>
+      </p:sp>
+      <p:sp>
+        <p:nvSpPr>
+          <p:cNvPr id="9" name="Rounded Rectangle 8"/>
           <p:cNvSpPr/>
           <p:nvPr/>
         </p:nvSpPr>
         <p:spPr>
           <a:xfrm>
-            <a:off x="6263640" y="1965960"/>
-            <a:ext cx="5212080" cy="4389120"/>
+            <a:off x="6302959" y="1975104"/>
+            <a:ext cx="5193792" cy="4279392"/>
           </a:xfrm>
           <a:prstGeom prst="roundRect">
             <a:avLst/>
           </a:prstGeom>
           <a:solidFill>
-            <a:srgbClr val="111C34"/>
+            <a:srgbClr val="FFFFFF"/>
           </a:solidFill>
           <a:ln w="25400">
             <a:solidFill>
-              <a:srgbClr val="10B981"/>
+              <a:srgbClr val="A7F3D0"/>
             </a:solidFill>
           </a:ln>
         </p:spPr>
@@ -3432,7 +3475,7 @@
       </p:sp>
       <p:pic>
         <p:nvPicPr>
-          <p:cNvPr id="9" name="Picture 8" descr="home_page_english_1786640419564.png"/>
+          <p:cNvPr id="10" name="Picture 9" descr="home_page_english_1786640419564.png"/>
           <p:cNvPicPr>
             <a:picLocks noChangeAspect="1"/>
           </p:cNvPicPr>
@@ -3446,8 +3489,8 @@
         </p:blipFill>
         <p:spPr>
           <a:xfrm>
-            <a:off x="6309360" y="2011680"/>
-            <a:ext cx="5120640" cy="4297680"/>
+            <a:off x="6339535" y="2011680"/>
+            <a:ext cx="5120640" cy="4206240"/>
           </a:xfrm>
           <a:prstGeom prst="rect">
             <a:avLst/>
@@ -3456,13 +3499,13 @@
       </p:pic>
       <p:sp>
         <p:nvSpPr>
-          <p:cNvPr id="10" name="TextBox 9"/>
+          <p:cNvPr id="11" name="TextBox 10"/>
           <p:cNvSpPr txBox="1"/>
           <p:nvPr/>
         </p:nvSpPr>
         <p:spPr>
           <a:xfrm>
-            <a:off x="731520" y="6400800"/>
+            <a:off x="731520" y="6355080"/>
             <a:ext cx="10698480" cy="274320"/>
           </a:xfrm>
           <a:prstGeom prst="rect">
@@ -3479,12 +3522,12 @@
             <a:pPr>
               <a:defRPr sz="1000">
                 <a:solidFill>
-                  <a:srgbClr val="9CA3AF"/>
+                  <a:srgbClr val="64748B"/>
                 </a:solidFill>
               </a:defRPr>
             </a:pPr>
             <a:r>
-              <a:t>AgriVision AI Platform | SIH 2026 Internal Hackathon | IIT Jodhpur &amp; AIIMS Jodhpur</a:t>
+              <a:t>AgriVision AI Platform  •  SIH 2026 Internal Hackathon  •  IIT Jodhpur &amp; AIIMS Jodhpur</a:t>
             </a:r>
           </a:p>
         </p:txBody>
@@ -3522,7 +3565,7 @@
             <a:avLst/>
           </a:prstGeom>
           <a:solidFill>
-            <a:srgbClr val="0B1426"/>
+            <a:srgbClr val="F8FAFC"/>
           </a:solidFill>
           <a:ln>
             <a:noFill/>
@@ -3552,130 +3595,23 @@
       </p:sp>
       <p:sp>
         <p:nvSpPr>
-          <p:cNvPr id="3" name="TextBox 2"/>
-          <p:cNvSpPr txBox="1"/>
-          <p:nvPr/>
-        </p:nvSpPr>
-        <p:spPr>
-          <a:xfrm>
-            <a:off x="731520" y="457200"/>
-            <a:ext cx="10698480" cy="365760"/>
-          </a:xfrm>
-          <a:prstGeom prst="rect">
-            <a:avLst/>
-          </a:prstGeom>
-          <a:noFill/>
-        </p:spPr>
-        <p:txBody>
-          <a:bodyPr wrap="none">
-            <a:spAutoFit/>
-          </a:bodyPr>
-          <a:lstStyle/>
-          <a:p>
-            <a:pPr>
-              <a:defRPr sz="1100" b="1">
-                <a:solidFill>
-                  <a:srgbClr val="10B981"/>
-                </a:solidFill>
-              </a:defRPr>
-            </a:pPr>
-            <a:r>
-              <a:t>SLIDE 10 | CONCLUSION &amp; Q&amp;A</a:t>
-            </a:r>
-          </a:p>
-        </p:txBody>
-      </p:sp>
-      <p:sp>
-        <p:nvSpPr>
-          <p:cNvPr id="4" name="TextBox 3"/>
-          <p:cNvSpPr txBox="1"/>
-          <p:nvPr/>
-        </p:nvSpPr>
-        <p:spPr>
-          <a:xfrm>
-            <a:off x="731520" y="777240"/>
-            <a:ext cx="10698480" cy="731520"/>
-          </a:xfrm>
-          <a:prstGeom prst="rect">
-            <a:avLst/>
-          </a:prstGeom>
-          <a:noFill/>
-        </p:spPr>
-        <p:txBody>
-          <a:bodyPr wrap="none">
-            <a:spAutoFit/>
-          </a:bodyPr>
-          <a:lstStyle/>
-          <a:p>
-            <a:pPr>
-              <a:defRPr sz="2600" b="1">
-                <a:solidFill>
-                  <a:srgbClr val="FFFFFF"/>
-                </a:solidFill>
-              </a:defRPr>
-            </a:pPr>
-            <a:r>
-              <a:t>Summary &amp; Call to Action</a:t>
-            </a:r>
-          </a:p>
-        </p:txBody>
-      </p:sp>
-      <p:sp>
-        <p:nvSpPr>
-          <p:cNvPr id="5" name="TextBox 4"/>
-          <p:cNvSpPr txBox="1"/>
-          <p:nvPr/>
-        </p:nvSpPr>
-        <p:spPr>
-          <a:xfrm>
-            <a:off x="731520" y="1371600"/>
-            <a:ext cx="10698480" cy="457200"/>
-          </a:xfrm>
-          <a:prstGeom prst="rect">
-            <a:avLst/>
-          </a:prstGeom>
-          <a:noFill/>
-        </p:spPr>
-        <p:txBody>
-          <a:bodyPr wrap="none">
-            <a:spAutoFit/>
-          </a:bodyPr>
-          <a:lstStyle/>
-          <a:p>
-            <a:pPr>
-              <a:defRPr sz="1500" b="1">
-                <a:solidFill>
-                  <a:srgbClr val="34D399"/>
-                </a:solidFill>
-              </a:defRPr>
-            </a:pPr>
-            <a:r>
-              <a:t>Ready for SIH 2026 Internal Hackathon Evaluation</a:t>
-            </a:r>
-          </a:p>
-        </p:txBody>
-      </p:sp>
-      <p:sp>
-        <p:nvSpPr>
-          <p:cNvPr id="6" name="Rounded Rectangle 5"/>
+          <p:cNvPr id="3" name="Rectangle 2"/>
           <p:cNvSpPr/>
           <p:nvPr/>
         </p:nvSpPr>
         <p:spPr>
           <a:xfrm>
-            <a:off x="731520" y="2011680"/>
-            <a:ext cx="5303520" cy="4297680"/>
-          </a:xfrm>
-          <a:prstGeom prst="roundRect">
+            <a:off x="731520" y="365760"/>
+            <a:ext cx="10728655" cy="54864"/>
+          </a:xfrm>
+          <a:prstGeom prst="rect">
             <a:avLst/>
           </a:prstGeom>
           <a:solidFill>
-            <a:srgbClr val="111C34"/>
+            <a:srgbClr val="047857"/>
           </a:solidFill>
-          <a:ln w="19050">
-            <a:solidFill>
-              <a:srgbClr val="10B981"/>
-            </a:solidFill>
+          <a:ln>
+            <a:noFill/>
           </a:ln>
         </p:spPr>
         <p:style>
@@ -3702,14 +3638,164 @@
       </p:sp>
       <p:sp>
         <p:nvSpPr>
-          <p:cNvPr id="7" name="TextBox 6"/>
+          <p:cNvPr id="4" name="TextBox 3"/>
           <p:cNvSpPr txBox="1"/>
           <p:nvPr/>
         </p:nvSpPr>
         <p:spPr>
           <a:xfrm>
+            <a:off x="731520" y="502920"/>
+            <a:ext cx="10698480" cy="320040"/>
+          </a:xfrm>
+          <a:prstGeom prst="rect">
+            <a:avLst/>
+          </a:prstGeom>
+          <a:noFill/>
+        </p:spPr>
+        <p:txBody>
+          <a:bodyPr wrap="none">
+            <a:spAutoFit/>
+          </a:bodyPr>
+          <a:lstStyle/>
+          <a:p>
+            <a:pPr>
+              <a:defRPr sz="1100" b="1">
+                <a:solidFill>
+                  <a:srgbClr val="047857"/>
+                </a:solidFill>
+              </a:defRPr>
+            </a:pPr>
+            <a:r>
+              <a:t>SLIDE 10  |  CONCLUSION &amp; Q&amp;A</a:t>
+            </a:r>
+          </a:p>
+        </p:txBody>
+      </p:sp>
+      <p:sp>
+        <p:nvSpPr>
+          <p:cNvPr id="5" name="TextBox 4"/>
+          <p:cNvSpPr txBox="1"/>
+          <p:nvPr/>
+        </p:nvSpPr>
+        <p:spPr>
+          <a:xfrm>
+            <a:off x="731520" y="822960"/>
+            <a:ext cx="10698480" cy="685800"/>
+          </a:xfrm>
+          <a:prstGeom prst="rect">
+            <a:avLst/>
+          </a:prstGeom>
+          <a:noFill/>
+        </p:spPr>
+        <p:txBody>
+          <a:bodyPr wrap="none">
+            <a:spAutoFit/>
+          </a:bodyPr>
+          <a:lstStyle/>
+          <a:p>
+            <a:pPr>
+              <a:defRPr sz="2600" b="1">
+                <a:solidFill>
+                  <a:srgbClr val="065F46"/>
+                </a:solidFill>
+              </a:defRPr>
+            </a:pPr>
+            <a:r>
+              <a:t>Summary &amp; Call to Action</a:t>
+            </a:r>
+          </a:p>
+        </p:txBody>
+      </p:sp>
+      <p:sp>
+        <p:nvSpPr>
+          <p:cNvPr id="6" name="TextBox 5"/>
+          <p:cNvSpPr txBox="1"/>
+          <p:nvPr/>
+        </p:nvSpPr>
+        <p:spPr>
+          <a:xfrm>
+            <a:off x="731520" y="1463040"/>
+            <a:ext cx="10698480" cy="411480"/>
+          </a:xfrm>
+          <a:prstGeom prst="rect">
+            <a:avLst/>
+          </a:prstGeom>
+          <a:noFill/>
+        </p:spPr>
+        <p:txBody>
+          <a:bodyPr wrap="none">
+            <a:spAutoFit/>
+          </a:bodyPr>
+          <a:lstStyle/>
+          <a:p>
+            <a:pPr>
+              <a:defRPr sz="1500" b="1">
+                <a:solidFill>
+                  <a:srgbClr val="0D9488"/>
+                </a:solidFill>
+              </a:defRPr>
+            </a:pPr>
+            <a:r>
+              <a:t>Ready for SIH 2026 Internal Hackathon Evaluation</a:t>
+            </a:r>
+          </a:p>
+        </p:txBody>
+      </p:sp>
+      <p:sp>
+        <p:nvSpPr>
+          <p:cNvPr id="7" name="Rounded Rectangle 6"/>
+          <p:cNvSpPr/>
+          <p:nvPr/>
+        </p:nvSpPr>
+        <p:spPr>
+          <a:xfrm>
+            <a:off x="731520" y="2011680"/>
+            <a:ext cx="5303520" cy="4206240"/>
+          </a:xfrm>
+          <a:prstGeom prst="roundRect">
+            <a:avLst/>
+          </a:prstGeom>
+          <a:solidFill>
+            <a:srgbClr val="F0FDF4"/>
+          </a:solidFill>
+          <a:ln w="19050">
+            <a:solidFill>
+              <a:srgbClr val="A7F3D0"/>
+            </a:solidFill>
+          </a:ln>
+        </p:spPr>
+        <p:style>
+          <a:lnRef idx="1">
+            <a:schemeClr val="accent1"/>
+          </a:lnRef>
+          <a:fillRef idx="3">
+            <a:schemeClr val="accent1"/>
+          </a:fillRef>
+          <a:effectRef idx="2">
+            <a:schemeClr val="accent1"/>
+          </a:effectRef>
+          <a:fontRef idx="minor">
+            <a:schemeClr val="lt1"/>
+          </a:fontRef>
+        </p:style>
+        <p:txBody>
+          <a:bodyPr rtlCol="0" anchor="ctr"/>
+          <a:lstStyle/>
+          <a:p>
+            <a:pPr algn="ctr"/>
+          </a:p>
+        </p:txBody>
+      </p:sp>
+      <p:sp>
+        <p:nvSpPr>
+          <p:cNvPr id="8" name="TextBox 7"/>
+          <p:cNvSpPr txBox="1"/>
+          <p:nvPr/>
+        </p:nvSpPr>
+        <p:spPr>
+          <a:xfrm>
             <a:off x="914400" y="2194560"/>
-            <a:ext cx="4937760" cy="3931920"/>
+            <a:ext cx="4937760" cy="3840480"/>
           </a:xfrm>
           <a:prstGeom prst="rect">
             <a:avLst/>
@@ -3724,79 +3810,79 @@
           <a:p>
             <a:pPr>
               <a:lnSpc>
-                <a:spcPct val="120000"/>
+                <a:spcPct val="125000"/>
               </a:lnSpc>
               <a:spcAft>
                 <a:spcPts val="1400"/>
               </a:spcAft>
               <a:defRPr sz="1400">
                 <a:solidFill>
-                  <a:srgbClr val="F3F4F6"/>
+                  <a:srgbClr val="1E293B"/>
                 </a:solidFill>
               </a:defRPr>
             </a:pPr>
             <a:r>
-              <a:t>• 100% Mandate Fulfilled: Crop AI, Livestock Triage, Farm Records, Advisory Services, &amp; Outbreak Radar in one app.</a:t>
+              <a:t>✔  100% Mandate Fulfilled: Crop AI, Livestock Triage, Farm Records, Advisory Services, &amp; Outbreak Radar in one app.</a:t>
             </a:r>
           </a:p>
           <a:p>
             <a:pPr>
               <a:lnSpc>
-                <a:spcPct val="120000"/>
+                <a:spcPct val="125000"/>
               </a:lnSpc>
               <a:spcAft>
                 <a:spcPts val="1400"/>
               </a:spcAft>
               <a:defRPr sz="1400">
                 <a:solidFill>
-                  <a:srgbClr val="F3F4F6"/>
+                  <a:srgbClr val="1E293B"/>
                 </a:solidFill>
               </a:defRPr>
             </a:pPr>
             <a:r>
-              <a:t>• Fully Functional Live Product: Tested with real crop leaves, cattle lesion photos, and multi-lingual voice audio.</a:t>
+              <a:t>✔  Fully Functional Live Product: Tested with real crop leaves, cattle lesion photos, and multi-lingual voice audio.</a:t>
             </a:r>
           </a:p>
           <a:p>
             <a:pPr>
               <a:lnSpc>
-                <a:spcPct val="120000"/>
+                <a:spcPct val="125000"/>
               </a:lnSpc>
               <a:spcAft>
                 <a:spcPts val="1400"/>
               </a:spcAft>
               <a:defRPr sz="1400">
                 <a:solidFill>
-                  <a:srgbClr val="F3F4F6"/>
+                  <a:srgbClr val="1E293B"/>
                 </a:solidFill>
               </a:defRPr>
             </a:pPr>
             <a:r>
-              <a:t>• Thank You! Team AgriVision AI (IIT Jodhpur) is Ready for Evaluator Q&amp;A &amp; Live Demonstration.</a:t>
-            </a:r>
-          </a:p>
-        </p:txBody>
-      </p:sp>
-      <p:sp>
-        <p:nvSpPr>
-          <p:cNvPr id="8" name="Rounded Rectangle 7"/>
+              <a:t>✔  Thank You! Team AgriVision AI (IIT Jodhpur) is Ready for Evaluator Q&amp;A &amp; Live Demonstration.</a:t>
+            </a:r>
+          </a:p>
+        </p:txBody>
+      </p:sp>
+      <p:sp>
+        <p:nvSpPr>
+          <p:cNvPr id="9" name="Rounded Rectangle 8"/>
           <p:cNvSpPr/>
           <p:nvPr/>
         </p:nvSpPr>
         <p:spPr>
           <a:xfrm>
-            <a:off x="6263640" y="1965960"/>
-            <a:ext cx="5212080" cy="4389120"/>
+            <a:off x="6302959" y="1975104"/>
+            <a:ext cx="5193792" cy="4279392"/>
           </a:xfrm>
           <a:prstGeom prst="roundRect">
             <a:avLst/>
           </a:prstGeom>
           <a:solidFill>
-            <a:srgbClr val="111C34"/>
+            <a:srgbClr val="FFFFFF"/>
           </a:solidFill>
           <a:ln w="25400">
             <a:solidFill>
-              <a:srgbClr val="10B981"/>
+              <a:srgbClr val="A7F3D0"/>
             </a:solidFill>
           </a:ln>
         </p:spPr>
@@ -3824,7 +3910,7 @@
       </p:sp>
       <p:pic>
         <p:nvPicPr>
-          <p:cNvPr id="9" name="Picture 8" descr="home_page_english_1786640419564.png"/>
+          <p:cNvPr id="10" name="Picture 9" descr="home_page_english_1786640419564.png"/>
           <p:cNvPicPr>
             <a:picLocks noChangeAspect="1"/>
           </p:cNvPicPr>
@@ -3838,8 +3924,8 @@
         </p:blipFill>
         <p:spPr>
           <a:xfrm>
-            <a:off x="6309360" y="2011680"/>
-            <a:ext cx="5120640" cy="4297680"/>
+            <a:off x="6339535" y="2011680"/>
+            <a:ext cx="5120640" cy="4206240"/>
           </a:xfrm>
           <a:prstGeom prst="rect">
             <a:avLst/>
@@ -3848,13 +3934,13 @@
       </p:pic>
       <p:sp>
         <p:nvSpPr>
-          <p:cNvPr id="10" name="TextBox 9"/>
+          <p:cNvPr id="11" name="TextBox 10"/>
           <p:cNvSpPr txBox="1"/>
           <p:nvPr/>
         </p:nvSpPr>
         <p:spPr>
           <a:xfrm>
-            <a:off x="731520" y="6400800"/>
+            <a:off x="731520" y="6355080"/>
             <a:ext cx="10698480" cy="274320"/>
           </a:xfrm>
           <a:prstGeom prst="rect">
@@ -3871,12 +3957,12 @@
             <a:pPr>
               <a:defRPr sz="1000">
                 <a:solidFill>
-                  <a:srgbClr val="9CA3AF"/>
+                  <a:srgbClr val="64748B"/>
                 </a:solidFill>
               </a:defRPr>
             </a:pPr>
             <a:r>
-              <a:t>AgriVision AI Platform | SIH 2026 Internal Hackathon | IIT Jodhpur &amp; AIIMS Jodhpur</a:t>
+              <a:t>AgriVision AI Platform  •  SIH 2026 Internal Hackathon  •  IIT Jodhpur &amp; AIIMS Jodhpur</a:t>
             </a:r>
           </a:p>
         </p:txBody>
@@ -3914,7 +4000,7 @@
             <a:avLst/>
           </a:prstGeom>
           <a:solidFill>
-            <a:srgbClr val="0B1426"/>
+            <a:srgbClr val="F8FAFC"/>
           </a:solidFill>
           <a:ln>
             <a:noFill/>
@@ -3944,130 +4030,23 @@
       </p:sp>
       <p:sp>
         <p:nvSpPr>
-          <p:cNvPr id="3" name="TextBox 2"/>
-          <p:cNvSpPr txBox="1"/>
-          <p:nvPr/>
-        </p:nvSpPr>
-        <p:spPr>
-          <a:xfrm>
-            <a:off x="731520" y="457200"/>
-            <a:ext cx="10698480" cy="365760"/>
-          </a:xfrm>
-          <a:prstGeom prst="rect">
-            <a:avLst/>
-          </a:prstGeom>
-          <a:noFill/>
-        </p:spPr>
-        <p:txBody>
-          <a:bodyPr wrap="none">
-            <a:spAutoFit/>
-          </a:bodyPr>
-          <a:lstStyle/>
-          <a:p>
-            <a:pPr>
-              <a:defRPr sz="1100" b="1">
-                <a:solidFill>
-                  <a:srgbClr val="10B981"/>
-                </a:solidFill>
-              </a:defRPr>
-            </a:pPr>
-            <a:r>
-              <a:t>SLIDE 2 | PROBLEM &amp; RURAL IMPACT</a:t>
-            </a:r>
-          </a:p>
-        </p:txBody>
-      </p:sp>
-      <p:sp>
-        <p:nvSpPr>
-          <p:cNvPr id="4" name="TextBox 3"/>
-          <p:cNvSpPr txBox="1"/>
-          <p:nvPr/>
-        </p:nvSpPr>
-        <p:spPr>
-          <a:xfrm>
-            <a:off x="731520" y="777240"/>
-            <a:ext cx="10698480" cy="731520"/>
-          </a:xfrm>
-          <a:prstGeom prst="rect">
-            <a:avLst/>
-          </a:prstGeom>
-          <a:noFill/>
-        </p:spPr>
-        <p:txBody>
-          <a:bodyPr wrap="none">
-            <a:spAutoFit/>
-          </a:bodyPr>
-          <a:lstStyle/>
-          <a:p>
-            <a:pPr>
-              <a:defRPr sz="2600" b="1">
-                <a:solidFill>
-                  <a:srgbClr val="FFFFFF"/>
-                </a:solidFill>
-              </a:defRPr>
-            </a:pPr>
-            <a:r>
-              <a:t>The Rural Challenge: Fragmented Care &amp; Loss</a:t>
-            </a:r>
-          </a:p>
-        </p:txBody>
-      </p:sp>
-      <p:sp>
-        <p:nvSpPr>
-          <p:cNvPr id="5" name="TextBox 4"/>
-          <p:cNvSpPr txBox="1"/>
-          <p:nvPr/>
-        </p:nvSpPr>
-        <p:spPr>
-          <a:xfrm>
-            <a:off x="731520" y="1371600"/>
-            <a:ext cx="10698480" cy="457200"/>
-          </a:xfrm>
-          <a:prstGeom prst="rect">
-            <a:avLst/>
-          </a:prstGeom>
-          <a:noFill/>
-        </p:spPr>
-        <p:txBody>
-          <a:bodyPr wrap="none">
-            <a:spAutoFit/>
-          </a:bodyPr>
-          <a:lstStyle/>
-          <a:p>
-            <a:pPr>
-              <a:defRPr sz="1500" b="1">
-                <a:solidFill>
-                  <a:srgbClr val="34D399"/>
-                </a:solidFill>
-              </a:defRPr>
-            </a:pPr>
-            <a:r>
-              <a:t>Why 120M+ Indian Farmers Suffer Severe Annual Losses</a:t>
-            </a:r>
-          </a:p>
-        </p:txBody>
-      </p:sp>
-      <p:sp>
-        <p:nvSpPr>
-          <p:cNvPr id="6" name="Rounded Rectangle 5"/>
+          <p:cNvPr id="3" name="Rectangle 2"/>
           <p:cNvSpPr/>
           <p:nvPr/>
         </p:nvSpPr>
         <p:spPr>
           <a:xfrm>
-            <a:off x="731520" y="2011680"/>
-            <a:ext cx="10698480" cy="4297680"/>
-          </a:xfrm>
-          <a:prstGeom prst="roundRect">
+            <a:off x="731520" y="365760"/>
+            <a:ext cx="10728655" cy="54864"/>
+          </a:xfrm>
+          <a:prstGeom prst="rect">
             <a:avLst/>
           </a:prstGeom>
           <a:solidFill>
-            <a:srgbClr val="111C34"/>
+            <a:srgbClr val="047857"/>
           </a:solidFill>
-          <a:ln w="19050">
-            <a:solidFill>
-              <a:srgbClr val="10B981"/>
-            </a:solidFill>
+          <a:ln>
+            <a:noFill/>
           </a:ln>
         </p:spPr>
         <p:style>
@@ -4094,14 +4073,164 @@
       </p:sp>
       <p:sp>
         <p:nvSpPr>
-          <p:cNvPr id="7" name="TextBox 6"/>
+          <p:cNvPr id="4" name="TextBox 3"/>
           <p:cNvSpPr txBox="1"/>
           <p:nvPr/>
         </p:nvSpPr>
         <p:spPr>
           <a:xfrm>
+            <a:off x="731520" y="502920"/>
+            <a:ext cx="10698480" cy="320040"/>
+          </a:xfrm>
+          <a:prstGeom prst="rect">
+            <a:avLst/>
+          </a:prstGeom>
+          <a:noFill/>
+        </p:spPr>
+        <p:txBody>
+          <a:bodyPr wrap="none">
+            <a:spAutoFit/>
+          </a:bodyPr>
+          <a:lstStyle/>
+          <a:p>
+            <a:pPr>
+              <a:defRPr sz="1100" b="1">
+                <a:solidFill>
+                  <a:srgbClr val="047857"/>
+                </a:solidFill>
+              </a:defRPr>
+            </a:pPr>
+            <a:r>
+              <a:t>SLIDE 2  |  PROBLEM &amp; RURAL IMPACT</a:t>
+            </a:r>
+          </a:p>
+        </p:txBody>
+      </p:sp>
+      <p:sp>
+        <p:nvSpPr>
+          <p:cNvPr id="5" name="TextBox 4"/>
+          <p:cNvSpPr txBox="1"/>
+          <p:nvPr/>
+        </p:nvSpPr>
+        <p:spPr>
+          <a:xfrm>
+            <a:off x="731520" y="822960"/>
+            <a:ext cx="10698480" cy="685800"/>
+          </a:xfrm>
+          <a:prstGeom prst="rect">
+            <a:avLst/>
+          </a:prstGeom>
+          <a:noFill/>
+        </p:spPr>
+        <p:txBody>
+          <a:bodyPr wrap="none">
+            <a:spAutoFit/>
+          </a:bodyPr>
+          <a:lstStyle/>
+          <a:p>
+            <a:pPr>
+              <a:defRPr sz="2600" b="1">
+                <a:solidFill>
+                  <a:srgbClr val="065F46"/>
+                </a:solidFill>
+              </a:defRPr>
+            </a:pPr>
+            <a:r>
+              <a:t>The Rural Challenge: Fragmented Care &amp; Loss</a:t>
+            </a:r>
+          </a:p>
+        </p:txBody>
+      </p:sp>
+      <p:sp>
+        <p:nvSpPr>
+          <p:cNvPr id="6" name="TextBox 5"/>
+          <p:cNvSpPr txBox="1"/>
+          <p:nvPr/>
+        </p:nvSpPr>
+        <p:spPr>
+          <a:xfrm>
+            <a:off x="731520" y="1463040"/>
+            <a:ext cx="10698480" cy="411480"/>
+          </a:xfrm>
+          <a:prstGeom prst="rect">
+            <a:avLst/>
+          </a:prstGeom>
+          <a:noFill/>
+        </p:spPr>
+        <p:txBody>
+          <a:bodyPr wrap="none">
+            <a:spAutoFit/>
+          </a:bodyPr>
+          <a:lstStyle/>
+          <a:p>
+            <a:pPr>
+              <a:defRPr sz="1500" b="1">
+                <a:solidFill>
+                  <a:srgbClr val="0D9488"/>
+                </a:solidFill>
+              </a:defRPr>
+            </a:pPr>
+            <a:r>
+              <a:t>Why 120M+ Indian Farmers Suffer Severe Annual Losses</a:t>
+            </a:r>
+          </a:p>
+        </p:txBody>
+      </p:sp>
+      <p:sp>
+        <p:nvSpPr>
+          <p:cNvPr id="7" name="Rounded Rectangle 6"/>
+          <p:cNvSpPr/>
+          <p:nvPr/>
+        </p:nvSpPr>
+        <p:spPr>
+          <a:xfrm>
+            <a:off x="731520" y="2011680"/>
+            <a:ext cx="10728655" cy="4206240"/>
+          </a:xfrm>
+          <a:prstGeom prst="roundRect">
+            <a:avLst/>
+          </a:prstGeom>
+          <a:solidFill>
+            <a:srgbClr val="F0FDF4"/>
+          </a:solidFill>
+          <a:ln w="19050">
+            <a:solidFill>
+              <a:srgbClr val="A7F3D0"/>
+            </a:solidFill>
+          </a:ln>
+        </p:spPr>
+        <p:style>
+          <a:lnRef idx="1">
+            <a:schemeClr val="accent1"/>
+          </a:lnRef>
+          <a:fillRef idx="3">
+            <a:schemeClr val="accent1"/>
+          </a:fillRef>
+          <a:effectRef idx="2">
+            <a:schemeClr val="accent1"/>
+          </a:effectRef>
+          <a:fontRef idx="minor">
+            <a:schemeClr val="lt1"/>
+          </a:fontRef>
+        </p:style>
+        <p:txBody>
+          <a:bodyPr rtlCol="0" anchor="ctr"/>
+          <a:lstStyle/>
+          <a:p>
+            <a:pPr algn="ctr"/>
+          </a:p>
+        </p:txBody>
+      </p:sp>
+      <p:sp>
+        <p:nvSpPr>
+          <p:cNvPr id="8" name="TextBox 7"/>
+          <p:cNvSpPr txBox="1"/>
+          <p:nvPr/>
+        </p:nvSpPr>
+        <p:spPr>
+          <a:xfrm>
             <a:off x="914400" y="2194560"/>
-            <a:ext cx="10332720" cy="3931920"/>
+            <a:ext cx="10362895" cy="3840480"/>
           </a:xfrm>
           <a:prstGeom prst="rect">
             <a:avLst/>
@@ -4116,68 +4245,68 @@
           <a:p>
             <a:pPr>
               <a:lnSpc>
-                <a:spcPct val="120000"/>
+                <a:spcPct val="125000"/>
               </a:lnSpc>
               <a:spcAft>
                 <a:spcPts val="1400"/>
               </a:spcAft>
               <a:defRPr sz="1400">
                 <a:solidFill>
-                  <a:srgbClr val="F3F4F6"/>
+                  <a:srgbClr val="1E293B"/>
                 </a:solidFill>
               </a:defRPr>
             </a:pPr>
             <a:r>
-              <a:t>• Separated Systems: Farmers rely on fragmented crop tools with ZERO digital diagnostic systems for livestock.</a:t>
+              <a:t>✔  Separated Systems: Farmers rely on fragmented crop tools with ZERO digital diagnostic systems for livestock.</a:t>
             </a:r>
           </a:p>
           <a:p>
             <a:pPr>
               <a:lnSpc>
-                <a:spcPct val="120000"/>
+                <a:spcPct val="125000"/>
               </a:lnSpc>
               <a:spcAft>
                 <a:spcPts val="1400"/>
               </a:spcAft>
               <a:defRPr sz="1400">
                 <a:solidFill>
-                  <a:srgbClr val="F3F4F6"/>
+                  <a:srgbClr val="1E293B"/>
                 </a:solidFill>
               </a:defRPr>
             </a:pPr>
             <a:r>
-              <a:t>• Acute Specialist Deficit: Severe shortage of rural agronomists &amp; vets (1 veterinarian per 15,000+ livestock in India).</a:t>
+              <a:t>✔  Acute Specialist Deficit: Severe shortage of rural agronomists &amp; vets (1 veterinarian per 15,000+ livestock in India).</a:t>
             </a:r>
           </a:p>
           <a:p>
             <a:pPr>
               <a:lnSpc>
-                <a:spcPct val="120000"/>
+                <a:spcPct val="125000"/>
               </a:lnSpc>
               <a:spcAft>
                 <a:spcPts val="1400"/>
               </a:spcAft>
               <a:defRPr sz="1400">
                 <a:solidFill>
-                  <a:srgbClr val="F3F4F6"/>
+                  <a:srgbClr val="1E293B"/>
                 </a:solidFill>
               </a:defRPr>
             </a:pPr>
             <a:r>
-              <a:t>• Catastrophic Shocks: Lumpy Skin Disease &amp; fungal crop blights devastate family incomes within 48 hours.</a:t>
-            </a:r>
-          </a:p>
-        </p:txBody>
-      </p:sp>
-      <p:sp>
-        <p:nvSpPr>
-          <p:cNvPr id="8" name="TextBox 7"/>
+              <a:t>✔  Catastrophic Shocks: Lumpy Skin Disease &amp; fungal crop blights devastate family incomes within 48 hours.</a:t>
+            </a:r>
+          </a:p>
+        </p:txBody>
+      </p:sp>
+      <p:sp>
+        <p:nvSpPr>
+          <p:cNvPr id="9" name="TextBox 8"/>
           <p:cNvSpPr txBox="1"/>
           <p:nvPr/>
         </p:nvSpPr>
         <p:spPr>
           <a:xfrm>
-            <a:off x="731520" y="6400800"/>
+            <a:off x="731520" y="6355080"/>
             <a:ext cx="10698480" cy="274320"/>
           </a:xfrm>
           <a:prstGeom prst="rect">
@@ -4194,12 +4323,12 @@
             <a:pPr>
               <a:defRPr sz="1000">
                 <a:solidFill>
-                  <a:srgbClr val="9CA3AF"/>
+                  <a:srgbClr val="64748B"/>
                 </a:solidFill>
               </a:defRPr>
             </a:pPr>
             <a:r>
-              <a:t>AgriVision AI Platform | SIH 2026 Internal Hackathon | IIT Jodhpur &amp; AIIMS Jodhpur</a:t>
+              <a:t>AgriVision AI Platform  •  SIH 2026 Internal Hackathon  •  IIT Jodhpur &amp; AIIMS Jodhpur</a:t>
             </a:r>
           </a:p>
         </p:txBody>
@@ -4237,7 +4366,7 @@
             <a:avLst/>
           </a:prstGeom>
           <a:solidFill>
-            <a:srgbClr val="0B1426"/>
+            <a:srgbClr val="F8FAFC"/>
           </a:solidFill>
           <a:ln>
             <a:noFill/>
@@ -4267,130 +4396,23 @@
       </p:sp>
       <p:sp>
         <p:nvSpPr>
-          <p:cNvPr id="3" name="TextBox 2"/>
-          <p:cNvSpPr txBox="1"/>
-          <p:nvPr/>
-        </p:nvSpPr>
-        <p:spPr>
-          <a:xfrm>
-            <a:off x="731520" y="457200"/>
-            <a:ext cx="10698480" cy="365760"/>
-          </a:xfrm>
-          <a:prstGeom prst="rect">
-            <a:avLst/>
-          </a:prstGeom>
-          <a:noFill/>
-        </p:spPr>
-        <p:txBody>
-          <a:bodyPr wrap="none">
-            <a:spAutoFit/>
-          </a:bodyPr>
-          <a:lstStyle/>
-          <a:p>
-            <a:pPr>
-              <a:defRPr sz="1100" b="1">
-                <a:solidFill>
-                  <a:srgbClr val="10B981"/>
-                </a:solidFill>
-              </a:defRPr>
-            </a:pPr>
-            <a:r>
-              <a:t>SLIDE 3 | CORE INNOVATION &amp; ARCHITECTURE</a:t>
-            </a:r>
-          </a:p>
-        </p:txBody>
-      </p:sp>
-      <p:sp>
-        <p:nvSpPr>
-          <p:cNvPr id="4" name="TextBox 3"/>
-          <p:cNvSpPr txBox="1"/>
-          <p:nvPr/>
-        </p:nvSpPr>
-        <p:spPr>
-          <a:xfrm>
-            <a:off x="731520" y="777240"/>
-            <a:ext cx="10698480" cy="731520"/>
-          </a:xfrm>
-          <a:prstGeom prst="rect">
-            <a:avLst/>
-          </a:prstGeom>
-          <a:noFill/>
-        </p:spPr>
-        <p:txBody>
-          <a:bodyPr wrap="none">
-            <a:spAutoFit/>
-          </a:bodyPr>
-          <a:lstStyle/>
-          <a:p>
-            <a:pPr>
-              <a:defRPr sz="2600" b="1">
-                <a:solidFill>
-                  <a:srgbClr val="FFFFFF"/>
-                </a:solidFill>
-              </a:defRPr>
-            </a:pPr>
-            <a:r>
-              <a:t>The Solution: Unified Dual-Domain AI Architecture</a:t>
-            </a:r>
-          </a:p>
-        </p:txBody>
-      </p:sp>
-      <p:sp>
-        <p:nvSpPr>
-          <p:cNvPr id="5" name="TextBox 4"/>
-          <p:cNvSpPr txBox="1"/>
-          <p:nvPr/>
-        </p:nvSpPr>
-        <p:spPr>
-          <a:xfrm>
-            <a:off x="731520" y="1371600"/>
-            <a:ext cx="10698480" cy="457200"/>
-          </a:xfrm>
-          <a:prstGeom prst="rect">
-            <a:avLst/>
-          </a:prstGeom>
-          <a:noFill/>
-        </p:spPr>
-        <p:txBody>
-          <a:bodyPr wrap="none">
-            <a:spAutoFit/>
-          </a:bodyPr>
-          <a:lstStyle/>
-          <a:p>
-            <a:pPr>
-              <a:defRPr sz="1500" b="1">
-                <a:solidFill>
-                  <a:srgbClr val="34D399"/>
-                </a:solidFill>
-              </a:defRPr>
-            </a:pPr>
-            <a:r>
-              <a:t>Single Digital Gateway for Crop Pathology + Livestock Clinical Triage</a:t>
-            </a:r>
-          </a:p>
-        </p:txBody>
-      </p:sp>
-      <p:sp>
-        <p:nvSpPr>
-          <p:cNvPr id="6" name="Rounded Rectangle 5"/>
+          <p:cNvPr id="3" name="Rectangle 2"/>
           <p:cNvSpPr/>
           <p:nvPr/>
         </p:nvSpPr>
         <p:spPr>
           <a:xfrm>
-            <a:off x="731520" y="2011680"/>
-            <a:ext cx="5303520" cy="4297680"/>
-          </a:xfrm>
-          <a:prstGeom prst="roundRect">
+            <a:off x="731520" y="365760"/>
+            <a:ext cx="10728655" cy="54864"/>
+          </a:xfrm>
+          <a:prstGeom prst="rect">
             <a:avLst/>
           </a:prstGeom>
           <a:solidFill>
-            <a:srgbClr val="111C34"/>
+            <a:srgbClr val="047857"/>
           </a:solidFill>
-          <a:ln w="19050">
-            <a:solidFill>
-              <a:srgbClr val="10B981"/>
-            </a:solidFill>
+          <a:ln>
+            <a:noFill/>
           </a:ln>
         </p:spPr>
         <p:style>
@@ -4417,14 +4439,164 @@
       </p:sp>
       <p:sp>
         <p:nvSpPr>
-          <p:cNvPr id="7" name="TextBox 6"/>
+          <p:cNvPr id="4" name="TextBox 3"/>
           <p:cNvSpPr txBox="1"/>
           <p:nvPr/>
         </p:nvSpPr>
         <p:spPr>
           <a:xfrm>
+            <a:off x="731520" y="502920"/>
+            <a:ext cx="10698480" cy="320040"/>
+          </a:xfrm>
+          <a:prstGeom prst="rect">
+            <a:avLst/>
+          </a:prstGeom>
+          <a:noFill/>
+        </p:spPr>
+        <p:txBody>
+          <a:bodyPr wrap="none">
+            <a:spAutoFit/>
+          </a:bodyPr>
+          <a:lstStyle/>
+          <a:p>
+            <a:pPr>
+              <a:defRPr sz="1100" b="1">
+                <a:solidFill>
+                  <a:srgbClr val="047857"/>
+                </a:solidFill>
+              </a:defRPr>
+            </a:pPr>
+            <a:r>
+              <a:t>SLIDE 3  |  CORE INNOVATION &amp; ARCHITECTURE</a:t>
+            </a:r>
+          </a:p>
+        </p:txBody>
+      </p:sp>
+      <p:sp>
+        <p:nvSpPr>
+          <p:cNvPr id="5" name="TextBox 4"/>
+          <p:cNvSpPr txBox="1"/>
+          <p:nvPr/>
+        </p:nvSpPr>
+        <p:spPr>
+          <a:xfrm>
+            <a:off x="731520" y="822960"/>
+            <a:ext cx="10698480" cy="685800"/>
+          </a:xfrm>
+          <a:prstGeom prst="rect">
+            <a:avLst/>
+          </a:prstGeom>
+          <a:noFill/>
+        </p:spPr>
+        <p:txBody>
+          <a:bodyPr wrap="none">
+            <a:spAutoFit/>
+          </a:bodyPr>
+          <a:lstStyle/>
+          <a:p>
+            <a:pPr>
+              <a:defRPr sz="2600" b="1">
+                <a:solidFill>
+                  <a:srgbClr val="065F46"/>
+                </a:solidFill>
+              </a:defRPr>
+            </a:pPr>
+            <a:r>
+              <a:t>The Solution: Unified Dual-Domain AI Architecture</a:t>
+            </a:r>
+          </a:p>
+        </p:txBody>
+      </p:sp>
+      <p:sp>
+        <p:nvSpPr>
+          <p:cNvPr id="6" name="TextBox 5"/>
+          <p:cNvSpPr txBox="1"/>
+          <p:nvPr/>
+        </p:nvSpPr>
+        <p:spPr>
+          <a:xfrm>
+            <a:off x="731520" y="1463040"/>
+            <a:ext cx="10698480" cy="411480"/>
+          </a:xfrm>
+          <a:prstGeom prst="rect">
+            <a:avLst/>
+          </a:prstGeom>
+          <a:noFill/>
+        </p:spPr>
+        <p:txBody>
+          <a:bodyPr wrap="none">
+            <a:spAutoFit/>
+          </a:bodyPr>
+          <a:lstStyle/>
+          <a:p>
+            <a:pPr>
+              <a:defRPr sz="1500" b="1">
+                <a:solidFill>
+                  <a:srgbClr val="0D9488"/>
+                </a:solidFill>
+              </a:defRPr>
+            </a:pPr>
+            <a:r>
+              <a:t>Single Digital Gateway for Crop Pathology + Livestock Clinical Triage</a:t>
+            </a:r>
+          </a:p>
+        </p:txBody>
+      </p:sp>
+      <p:sp>
+        <p:nvSpPr>
+          <p:cNvPr id="7" name="Rounded Rectangle 6"/>
+          <p:cNvSpPr/>
+          <p:nvPr/>
+        </p:nvSpPr>
+        <p:spPr>
+          <a:xfrm>
+            <a:off x="731520" y="2011680"/>
+            <a:ext cx="5303520" cy="4206240"/>
+          </a:xfrm>
+          <a:prstGeom prst="roundRect">
+            <a:avLst/>
+          </a:prstGeom>
+          <a:solidFill>
+            <a:srgbClr val="F0FDF4"/>
+          </a:solidFill>
+          <a:ln w="19050">
+            <a:solidFill>
+              <a:srgbClr val="A7F3D0"/>
+            </a:solidFill>
+          </a:ln>
+        </p:spPr>
+        <p:style>
+          <a:lnRef idx="1">
+            <a:schemeClr val="accent1"/>
+          </a:lnRef>
+          <a:fillRef idx="3">
+            <a:schemeClr val="accent1"/>
+          </a:fillRef>
+          <a:effectRef idx="2">
+            <a:schemeClr val="accent1"/>
+          </a:effectRef>
+          <a:fontRef idx="minor">
+            <a:schemeClr val="lt1"/>
+          </a:fontRef>
+        </p:style>
+        <p:txBody>
+          <a:bodyPr rtlCol="0" anchor="ctr"/>
+          <a:lstStyle/>
+          <a:p>
+            <a:pPr algn="ctr"/>
+          </a:p>
+        </p:txBody>
+      </p:sp>
+      <p:sp>
+        <p:nvSpPr>
+          <p:cNvPr id="8" name="TextBox 7"/>
+          <p:cNvSpPr txBox="1"/>
+          <p:nvPr/>
+        </p:nvSpPr>
+        <p:spPr>
+          <a:xfrm>
             <a:off x="914400" y="2194560"/>
-            <a:ext cx="4937760" cy="3931920"/>
+            <a:ext cx="4937760" cy="3840480"/>
           </a:xfrm>
           <a:prstGeom prst="rect">
             <a:avLst/>
@@ -4439,79 +4611,79 @@
           <a:p>
             <a:pPr>
               <a:lnSpc>
-                <a:spcPct val="120000"/>
+                <a:spcPct val="125000"/>
               </a:lnSpc>
               <a:spcAft>
                 <a:spcPts val="1400"/>
               </a:spcAft>
               <a:defRPr sz="1400">
                 <a:solidFill>
-                  <a:srgbClr val="F3F4F6"/>
+                  <a:srgbClr val="1E293B"/>
                 </a:solidFill>
               </a:defRPr>
             </a:pPr>
             <a:r>
-              <a:t>• Integrated Doorway: Crop disease detection AND livestock health triage in ONE intuitive interface.</a:t>
+              <a:t>✔  Integrated Doorway: Crop disease detection AND livestock health triage in ONE intuitive interface.</a:t>
             </a:r>
           </a:p>
           <a:p>
             <a:pPr>
               <a:lnSpc>
-                <a:spcPct val="120000"/>
+                <a:spcPct val="125000"/>
               </a:lnSpc>
               <a:spcAft>
                 <a:spcPts val="1400"/>
               </a:spcAft>
               <a:defRPr sz="1400">
                 <a:solidFill>
-                  <a:srgbClr val="F3F4F6"/>
+                  <a:srgbClr val="1E293B"/>
                 </a:solidFill>
               </a:defRPr>
             </a:pPr>
             <a:r>
-              <a:t>• AIIMS Clinical Triage Protocol: Adapting medical emergency triage scoring to animal epidemiology.</a:t>
+              <a:t>✔  AIIMS Clinical Triage Protocol: Adapting medical emergency triage scoring to animal epidemiology.</a:t>
             </a:r>
           </a:p>
           <a:p>
             <a:pPr>
               <a:lnSpc>
-                <a:spcPct val="120000"/>
+                <a:spcPct val="125000"/>
               </a:lnSpc>
               <a:spcAft>
                 <a:spcPts val="1400"/>
               </a:spcAft>
               <a:defRPr sz="1400">
                 <a:solidFill>
-                  <a:srgbClr val="F3F4F6"/>
+                  <a:srgbClr val="1E293B"/>
                 </a:solidFill>
               </a:defRPr>
             </a:pPr>
             <a:r>
-              <a:t>• Hybrid AI Engine: Real-time Multimodal Neural Vision AI + Offline Rural Field Fallback.</a:t>
-            </a:r>
-          </a:p>
-        </p:txBody>
-      </p:sp>
-      <p:sp>
-        <p:nvSpPr>
-          <p:cNvPr id="8" name="Rounded Rectangle 7"/>
+              <a:t>✔  Hybrid AI Engine: Real-time Multimodal Neural Vision AI + Offline Rural Field Fallback.</a:t>
+            </a:r>
+          </a:p>
+        </p:txBody>
+      </p:sp>
+      <p:sp>
+        <p:nvSpPr>
+          <p:cNvPr id="9" name="Rounded Rectangle 8"/>
           <p:cNvSpPr/>
           <p:nvPr/>
         </p:nvSpPr>
         <p:spPr>
           <a:xfrm>
-            <a:off x="6263640" y="1965960"/>
-            <a:ext cx="5212080" cy="4389120"/>
+            <a:off x="6302959" y="1975104"/>
+            <a:ext cx="5193792" cy="4279392"/>
           </a:xfrm>
           <a:prstGeom prst="roundRect">
             <a:avLst/>
           </a:prstGeom>
           <a:solidFill>
-            <a:srgbClr val="111C34"/>
+            <a:srgbClr val="FFFFFF"/>
           </a:solidFill>
           <a:ln w="25400">
             <a:solidFill>
-              <a:srgbClr val="10B981"/>
+              <a:srgbClr val="A7F3D0"/>
             </a:solidFill>
           </a:ln>
         </p:spPr>
@@ -4539,7 +4711,7 @@
       </p:sp>
       <p:pic>
         <p:nvPicPr>
-          <p:cNvPr id="9" name="Picture 8" descr="home_page_english_1786640419564.png"/>
+          <p:cNvPr id="10" name="Picture 9" descr="home_page_english_1786640419564.png"/>
           <p:cNvPicPr>
             <a:picLocks noChangeAspect="1"/>
           </p:cNvPicPr>
@@ -4553,8 +4725,8 @@
         </p:blipFill>
         <p:spPr>
           <a:xfrm>
-            <a:off x="6309360" y="2011680"/>
-            <a:ext cx="5120640" cy="4297680"/>
+            <a:off x="6339535" y="2011680"/>
+            <a:ext cx="5120640" cy="4206240"/>
           </a:xfrm>
           <a:prstGeom prst="rect">
             <a:avLst/>
@@ -4563,13 +4735,13 @@
       </p:pic>
       <p:sp>
         <p:nvSpPr>
-          <p:cNvPr id="10" name="TextBox 9"/>
+          <p:cNvPr id="11" name="TextBox 10"/>
           <p:cNvSpPr txBox="1"/>
           <p:nvPr/>
         </p:nvSpPr>
         <p:spPr>
           <a:xfrm>
-            <a:off x="731520" y="6400800"/>
+            <a:off x="731520" y="6355080"/>
             <a:ext cx="10698480" cy="274320"/>
           </a:xfrm>
           <a:prstGeom prst="rect">
@@ -4586,12 +4758,12 @@
             <a:pPr>
               <a:defRPr sz="1000">
                 <a:solidFill>
-                  <a:srgbClr val="9CA3AF"/>
+                  <a:srgbClr val="64748B"/>
                 </a:solidFill>
               </a:defRPr>
             </a:pPr>
             <a:r>
-              <a:t>AgriVision AI Platform | SIH 2026 Internal Hackathon | IIT Jodhpur &amp; AIIMS Jodhpur</a:t>
+              <a:t>AgriVision AI Platform  •  SIH 2026 Internal Hackathon  •  IIT Jodhpur &amp; AIIMS Jodhpur</a:t>
             </a:r>
           </a:p>
         </p:txBody>
@@ -4629,7 +4801,7 @@
             <a:avLst/>
           </a:prstGeom>
           <a:solidFill>
-            <a:srgbClr val="0B1426"/>
+            <a:srgbClr val="F8FAFC"/>
           </a:solidFill>
           <a:ln>
             <a:noFill/>
@@ -4659,130 +4831,23 @@
       </p:sp>
       <p:sp>
         <p:nvSpPr>
-          <p:cNvPr id="3" name="TextBox 2"/>
-          <p:cNvSpPr txBox="1"/>
-          <p:nvPr/>
-        </p:nvSpPr>
-        <p:spPr>
-          <a:xfrm>
-            <a:off x="731520" y="457200"/>
-            <a:ext cx="10698480" cy="365760"/>
-          </a:xfrm>
-          <a:prstGeom prst="rect">
-            <a:avLst/>
-          </a:prstGeom>
-          <a:noFill/>
-        </p:spPr>
-        <p:txBody>
-          <a:bodyPr wrap="none">
-            <a:spAutoFit/>
-          </a:bodyPr>
-          <a:lstStyle/>
-          <a:p>
-            <a:pPr>
-              <a:defRPr sz="1100" b="1">
-                <a:solidFill>
-                  <a:srgbClr val="10B981"/>
-                </a:solidFill>
-              </a:defRPr>
-            </a:pPr>
-            <a:r>
-              <a:t>SLIDE 4 | CROP AI PATHOLOGY ENGINE</a:t>
-            </a:r>
-          </a:p>
-        </p:txBody>
-      </p:sp>
-      <p:sp>
-        <p:nvSpPr>
-          <p:cNvPr id="4" name="TextBox 3"/>
-          <p:cNvSpPr txBox="1"/>
-          <p:nvPr/>
-        </p:nvSpPr>
-        <p:spPr>
-          <a:xfrm>
-            <a:off x="731520" y="777240"/>
-            <a:ext cx="10698480" cy="731520"/>
-          </a:xfrm>
-          <a:prstGeom prst="rect">
-            <a:avLst/>
-          </a:prstGeom>
-          <a:noFill/>
-        </p:spPr>
-        <p:txBody>
-          <a:bodyPr wrap="none">
-            <a:spAutoFit/>
-          </a:bodyPr>
-          <a:lstStyle/>
-          <a:p>
-            <a:pPr>
-              <a:defRPr sz="2600" b="1">
-                <a:solidFill>
-                  <a:srgbClr val="FFFFFF"/>
-                </a:solidFill>
-              </a:defRPr>
-            </a:pPr>
-            <a:r>
-              <a:t>Live Crop Pathology &amp; ICAR Dosage Calculator</a:t>
-            </a:r>
-          </a:p>
-        </p:txBody>
-      </p:sp>
-      <p:sp>
-        <p:nvSpPr>
-          <p:cNvPr id="5" name="TextBox 4"/>
-          <p:cNvSpPr txBox="1"/>
-          <p:nvPr/>
-        </p:nvSpPr>
-        <p:spPr>
-          <a:xfrm>
-            <a:off x="731520" y="1371600"/>
-            <a:ext cx="10698480" cy="457200"/>
-          </a:xfrm>
-          <a:prstGeom prst="rect">
-            <a:avLst/>
-          </a:prstGeom>
-          <a:noFill/>
-        </p:spPr>
-        <p:txBody>
-          <a:bodyPr wrap="none">
-            <a:spAutoFit/>
-          </a:bodyPr>
-          <a:lstStyle/>
-          <a:p>
-            <a:pPr>
-              <a:defRPr sz="1500" b="1">
-                <a:solidFill>
-                  <a:srgbClr val="34D399"/>
-                </a:solidFill>
-              </a:defRPr>
-            </a:pPr>
-            <a:r>
-              <a:t>Multi-Image Selection, Live Camera Stream &amp; AI Heatmap Overlay</a:t>
-            </a:r>
-          </a:p>
-        </p:txBody>
-      </p:sp>
-      <p:sp>
-        <p:nvSpPr>
-          <p:cNvPr id="6" name="Rounded Rectangle 5"/>
+          <p:cNvPr id="3" name="Rectangle 2"/>
           <p:cNvSpPr/>
           <p:nvPr/>
         </p:nvSpPr>
         <p:spPr>
           <a:xfrm>
-            <a:off x="731520" y="2011680"/>
-            <a:ext cx="5303520" cy="4297680"/>
-          </a:xfrm>
-          <a:prstGeom prst="roundRect">
+            <a:off x="731520" y="365760"/>
+            <a:ext cx="10728655" cy="54864"/>
+          </a:xfrm>
+          <a:prstGeom prst="rect">
             <a:avLst/>
           </a:prstGeom>
           <a:solidFill>
-            <a:srgbClr val="111C34"/>
+            <a:srgbClr val="047857"/>
           </a:solidFill>
-          <a:ln w="19050">
-            <a:solidFill>
-              <a:srgbClr val="10B981"/>
-            </a:solidFill>
+          <a:ln>
+            <a:noFill/>
           </a:ln>
         </p:spPr>
         <p:style>
@@ -4809,14 +4874,164 @@
       </p:sp>
       <p:sp>
         <p:nvSpPr>
-          <p:cNvPr id="7" name="TextBox 6"/>
+          <p:cNvPr id="4" name="TextBox 3"/>
           <p:cNvSpPr txBox="1"/>
           <p:nvPr/>
         </p:nvSpPr>
         <p:spPr>
           <a:xfrm>
+            <a:off x="731520" y="502920"/>
+            <a:ext cx="10698480" cy="320040"/>
+          </a:xfrm>
+          <a:prstGeom prst="rect">
+            <a:avLst/>
+          </a:prstGeom>
+          <a:noFill/>
+        </p:spPr>
+        <p:txBody>
+          <a:bodyPr wrap="none">
+            <a:spAutoFit/>
+          </a:bodyPr>
+          <a:lstStyle/>
+          <a:p>
+            <a:pPr>
+              <a:defRPr sz="1100" b="1">
+                <a:solidFill>
+                  <a:srgbClr val="047857"/>
+                </a:solidFill>
+              </a:defRPr>
+            </a:pPr>
+            <a:r>
+              <a:t>SLIDE 4  |  CROP AI PATHOLOGY ENGINE</a:t>
+            </a:r>
+          </a:p>
+        </p:txBody>
+      </p:sp>
+      <p:sp>
+        <p:nvSpPr>
+          <p:cNvPr id="5" name="TextBox 4"/>
+          <p:cNvSpPr txBox="1"/>
+          <p:nvPr/>
+        </p:nvSpPr>
+        <p:spPr>
+          <a:xfrm>
+            <a:off x="731520" y="822960"/>
+            <a:ext cx="10698480" cy="685800"/>
+          </a:xfrm>
+          <a:prstGeom prst="rect">
+            <a:avLst/>
+          </a:prstGeom>
+          <a:noFill/>
+        </p:spPr>
+        <p:txBody>
+          <a:bodyPr wrap="none">
+            <a:spAutoFit/>
+          </a:bodyPr>
+          <a:lstStyle/>
+          <a:p>
+            <a:pPr>
+              <a:defRPr sz="2600" b="1">
+                <a:solidFill>
+                  <a:srgbClr val="065F46"/>
+                </a:solidFill>
+              </a:defRPr>
+            </a:pPr>
+            <a:r>
+              <a:t>Live Crop Pathology &amp; ICAR Dosage Calculator</a:t>
+            </a:r>
+          </a:p>
+        </p:txBody>
+      </p:sp>
+      <p:sp>
+        <p:nvSpPr>
+          <p:cNvPr id="6" name="TextBox 5"/>
+          <p:cNvSpPr txBox="1"/>
+          <p:nvPr/>
+        </p:nvSpPr>
+        <p:spPr>
+          <a:xfrm>
+            <a:off x="731520" y="1463040"/>
+            <a:ext cx="10698480" cy="411480"/>
+          </a:xfrm>
+          <a:prstGeom prst="rect">
+            <a:avLst/>
+          </a:prstGeom>
+          <a:noFill/>
+        </p:spPr>
+        <p:txBody>
+          <a:bodyPr wrap="none">
+            <a:spAutoFit/>
+          </a:bodyPr>
+          <a:lstStyle/>
+          <a:p>
+            <a:pPr>
+              <a:defRPr sz="1500" b="1">
+                <a:solidFill>
+                  <a:srgbClr val="0D9488"/>
+                </a:solidFill>
+              </a:defRPr>
+            </a:pPr>
+            <a:r>
+              <a:t>Multi-Image Selection, Live Camera Stream &amp; AI Heatmap Overlay</a:t>
+            </a:r>
+          </a:p>
+        </p:txBody>
+      </p:sp>
+      <p:sp>
+        <p:nvSpPr>
+          <p:cNvPr id="7" name="Rounded Rectangle 6"/>
+          <p:cNvSpPr/>
+          <p:nvPr/>
+        </p:nvSpPr>
+        <p:spPr>
+          <a:xfrm>
+            <a:off x="731520" y="2011680"/>
+            <a:ext cx="5303520" cy="4206240"/>
+          </a:xfrm>
+          <a:prstGeom prst="roundRect">
+            <a:avLst/>
+          </a:prstGeom>
+          <a:solidFill>
+            <a:srgbClr val="F0FDF4"/>
+          </a:solidFill>
+          <a:ln w="19050">
+            <a:solidFill>
+              <a:srgbClr val="A7F3D0"/>
+            </a:solidFill>
+          </a:ln>
+        </p:spPr>
+        <p:style>
+          <a:lnRef idx="1">
+            <a:schemeClr val="accent1"/>
+          </a:lnRef>
+          <a:fillRef idx="3">
+            <a:schemeClr val="accent1"/>
+          </a:fillRef>
+          <a:effectRef idx="2">
+            <a:schemeClr val="accent1"/>
+          </a:effectRef>
+          <a:fontRef idx="minor">
+            <a:schemeClr val="lt1"/>
+          </a:fontRef>
+        </p:style>
+        <p:txBody>
+          <a:bodyPr rtlCol="0" anchor="ctr"/>
+          <a:lstStyle/>
+          <a:p>
+            <a:pPr algn="ctr"/>
+          </a:p>
+        </p:txBody>
+      </p:sp>
+      <p:sp>
+        <p:nvSpPr>
+          <p:cNvPr id="8" name="TextBox 7"/>
+          <p:cNvSpPr txBox="1"/>
+          <p:nvPr/>
+        </p:nvSpPr>
+        <p:spPr>
+          <a:xfrm>
             <a:off x="914400" y="2194560"/>
-            <a:ext cx="4937760" cy="3931920"/>
+            <a:ext cx="4937760" cy="3840480"/>
           </a:xfrm>
           <a:prstGeom prst="rect">
             <a:avLst/>
@@ -4831,79 +5046,79 @@
           <a:p>
             <a:pPr>
               <a:lnSpc>
-                <a:spcPct val="120000"/>
+                <a:spcPct val="125000"/>
               </a:lnSpc>
               <a:spcAft>
                 <a:spcPts val="1400"/>
               </a:spcAft>
               <a:defRPr sz="1400">
                 <a:solidFill>
-                  <a:srgbClr val="F3F4F6"/>
+                  <a:srgbClr val="1E293B"/>
                 </a:solidFill>
               </a:defRPr>
             </a:pPr>
             <a:r>
-              <a:t>• Multi-Angle Photo Inspection: Upload up to 5 leaf photos or capture live stream via Mobile/Webcam.</a:t>
+              <a:t>✔  Multi-Angle Photo Inspection: Upload up to 5 leaf photos or capture live stream via Mobile/Webcam.</a:t>
             </a:r>
           </a:p>
           <a:p>
             <a:pPr>
               <a:lnSpc>
-                <a:spcPct val="120000"/>
+                <a:spcPct val="125000"/>
               </a:lnSpc>
               <a:spcAft>
                 <a:spcPts val="1400"/>
               </a:spcAft>
               <a:defRPr sz="1400">
                 <a:solidFill>
-                  <a:srgbClr val="F3F4F6"/>
+                  <a:srgbClr val="1E293B"/>
                 </a:solidFill>
               </a:defRPr>
             </a:pPr>
             <a:r>
-              <a:t>• AI Pathology Heatmap: Visual bounding overlay pinpointing exact leaf lesions and fungal spores.</a:t>
+              <a:t>✔  AI Pathology Heatmap: Visual bounding overlay pinpointing exact leaf lesions and fungal spores.</a:t>
             </a:r>
           </a:p>
           <a:p>
             <a:pPr>
               <a:lnSpc>
-                <a:spcPct val="120000"/>
+                <a:spcPct val="125000"/>
               </a:lnSpc>
               <a:spcAft>
                 <a:spcPts val="1400"/>
               </a:spcAft>
               <a:defRPr sz="1400">
                 <a:solidFill>
-                  <a:srgbClr val="F3F4F6"/>
+                  <a:srgbClr val="1E293B"/>
                 </a:solidFill>
               </a:defRPr>
             </a:pPr>
             <a:r>
-              <a:t>• ICAR Dosage Calculator: Computes exact chemical spray grams/liters &amp; tank refills based on land area.</a:t>
-            </a:r>
-          </a:p>
-        </p:txBody>
-      </p:sp>
-      <p:sp>
-        <p:nvSpPr>
-          <p:cNvPr id="8" name="Rounded Rectangle 7"/>
+              <a:t>✔  ICAR Dosage Calculator: Computes exact chemical spray grams/liters &amp; tank refills based on land area.</a:t>
+            </a:r>
+          </a:p>
+        </p:txBody>
+      </p:sp>
+      <p:sp>
+        <p:nvSpPr>
+          <p:cNvPr id="9" name="Rounded Rectangle 8"/>
           <p:cNvSpPr/>
           <p:nvPr/>
         </p:nvSpPr>
         <p:spPr>
           <a:xfrm>
-            <a:off x="6263640" y="1965960"/>
-            <a:ext cx="5212080" cy="4389120"/>
+            <a:off x="6302959" y="1975104"/>
+            <a:ext cx="5193792" cy="4279392"/>
           </a:xfrm>
           <a:prstGeom prst="roundRect">
             <a:avLst/>
           </a:prstGeom>
           <a:solidFill>
-            <a:srgbClr val="111C34"/>
+            <a:srgbClr val="FFFFFF"/>
           </a:solidFill>
           <a:ln w="25400">
             <a:solidFill>
-              <a:srgbClr val="10B981"/>
+              <a:srgbClr val="A7F3D0"/>
             </a:solidFill>
           </a:ln>
         </p:spPr>
@@ -4931,7 +5146,7 @@
       </p:sp>
       <p:pic>
         <p:nvPicPr>
-          <p:cNvPr id="9" name="Picture 8" descr="home_page_english_1786640419564.png"/>
+          <p:cNvPr id="10" name="Picture 9" descr="home_page_english_1786640419564.png"/>
           <p:cNvPicPr>
             <a:picLocks noChangeAspect="1"/>
           </p:cNvPicPr>
@@ -4945,8 +5160,8 @@
         </p:blipFill>
         <p:spPr>
           <a:xfrm>
-            <a:off x="6309360" y="2011680"/>
-            <a:ext cx="5120640" cy="4297680"/>
+            <a:off x="6339535" y="2011680"/>
+            <a:ext cx="5120640" cy="4206240"/>
           </a:xfrm>
           <a:prstGeom prst="rect">
             <a:avLst/>
@@ -4955,13 +5170,13 @@
       </p:pic>
       <p:sp>
         <p:nvSpPr>
-          <p:cNvPr id="10" name="TextBox 9"/>
+          <p:cNvPr id="11" name="TextBox 10"/>
           <p:cNvSpPr txBox="1"/>
           <p:nvPr/>
         </p:nvSpPr>
         <p:spPr>
           <a:xfrm>
-            <a:off x="731520" y="6400800"/>
+            <a:off x="731520" y="6355080"/>
             <a:ext cx="10698480" cy="274320"/>
           </a:xfrm>
           <a:prstGeom prst="rect">
@@ -4978,12 +5193,12 @@
             <a:pPr>
               <a:defRPr sz="1000">
                 <a:solidFill>
-                  <a:srgbClr val="9CA3AF"/>
+                  <a:srgbClr val="64748B"/>
                 </a:solidFill>
               </a:defRPr>
             </a:pPr>
             <a:r>
-              <a:t>AgriVision AI Platform | SIH 2026 Internal Hackathon | IIT Jodhpur &amp; AIIMS Jodhpur</a:t>
+              <a:t>AgriVision AI Platform  •  SIH 2026 Internal Hackathon  •  IIT Jodhpur &amp; AIIMS Jodhpur</a:t>
             </a:r>
           </a:p>
         </p:txBody>
@@ -5021,7 +5236,7 @@
             <a:avLst/>
           </a:prstGeom>
           <a:solidFill>
-            <a:srgbClr val="0B1426"/>
+            <a:srgbClr val="F8FAFC"/>
           </a:solidFill>
           <a:ln>
             <a:noFill/>
@@ -5051,130 +5266,23 @@
       </p:sp>
       <p:sp>
         <p:nvSpPr>
-          <p:cNvPr id="3" name="TextBox 2"/>
-          <p:cNvSpPr txBox="1"/>
-          <p:nvPr/>
-        </p:nvSpPr>
-        <p:spPr>
-          <a:xfrm>
-            <a:off x="731520" y="457200"/>
-            <a:ext cx="10698480" cy="365760"/>
-          </a:xfrm>
-          <a:prstGeom prst="rect">
-            <a:avLst/>
-          </a:prstGeom>
-          <a:noFill/>
-        </p:spPr>
-        <p:txBody>
-          <a:bodyPr wrap="none">
-            <a:spAutoFit/>
-          </a:bodyPr>
-          <a:lstStyle/>
-          <a:p>
-            <a:pPr>
-              <a:defRPr sz="1100" b="1">
-                <a:solidFill>
-                  <a:srgbClr val="10B981"/>
-                </a:solidFill>
-              </a:defRPr>
-            </a:pPr>
-            <a:r>
-              <a:t>SLIDE 5 | LIVESTOCK TRIAGE &amp; DIGITAL LEDGER</a:t>
-            </a:r>
-          </a:p>
-        </p:txBody>
-      </p:sp>
-      <p:sp>
-        <p:nvSpPr>
-          <p:cNvPr id="4" name="TextBox 3"/>
-          <p:cNvSpPr txBox="1"/>
-          <p:nvPr/>
-        </p:nvSpPr>
-        <p:spPr>
-          <a:xfrm>
-            <a:off x="731520" y="777240"/>
-            <a:ext cx="10698480" cy="731520"/>
-          </a:xfrm>
-          <a:prstGeom prst="rect">
-            <a:avLst/>
-          </a:prstGeom>
-          <a:noFill/>
-        </p:spPr>
-        <p:txBody>
-          <a:bodyPr wrap="none">
-            <a:spAutoFit/>
-          </a:bodyPr>
-          <a:lstStyle/>
-          <a:p>
-            <a:pPr>
-              <a:defRPr sz="2600" b="1">
-                <a:solidFill>
-                  <a:srgbClr val="FFFFFF"/>
-                </a:solidFill>
-              </a:defRPr>
-            </a:pPr>
-            <a:r>
-              <a:t>Livestock Emergency Health Triage &amp; Ledger</a:t>
-            </a:r>
-          </a:p>
-        </p:txBody>
-      </p:sp>
-      <p:sp>
-        <p:nvSpPr>
-          <p:cNvPr id="5" name="TextBox 4"/>
-          <p:cNvSpPr txBox="1"/>
-          <p:nvPr/>
-        </p:nvSpPr>
-        <p:spPr>
-          <a:xfrm>
-            <a:off x="731520" y="1371600"/>
-            <a:ext cx="10698480" cy="457200"/>
-          </a:xfrm>
-          <a:prstGeom prst="rect">
-            <a:avLst/>
-          </a:prstGeom>
-          <a:noFill/>
-        </p:spPr>
-        <p:txBody>
-          <a:bodyPr wrap="none">
-            <a:spAutoFit/>
-          </a:bodyPr>
-          <a:lstStyle/>
-          <a:p>
-            <a:pPr>
-              <a:defRPr sz="1500" b="1">
-                <a:solidFill>
-                  <a:srgbClr val="34D399"/>
-                </a:solidFill>
-              </a:defRPr>
-            </a:pPr>
-            <a:r>
-              <a:t>AIIMS Nursing Triage Protocol + 1-Click Sync to Digital Herd Ledger</a:t>
-            </a:r>
-          </a:p>
-        </p:txBody>
-      </p:sp>
-      <p:sp>
-        <p:nvSpPr>
-          <p:cNvPr id="6" name="Rounded Rectangle 5"/>
+          <p:cNvPr id="3" name="Rectangle 2"/>
           <p:cNvSpPr/>
           <p:nvPr/>
         </p:nvSpPr>
         <p:spPr>
           <a:xfrm>
-            <a:off x="731520" y="2011680"/>
-            <a:ext cx="5303520" cy="4297680"/>
-          </a:xfrm>
-          <a:prstGeom prst="roundRect">
+            <a:off x="731520" y="365760"/>
+            <a:ext cx="10728655" cy="54864"/>
+          </a:xfrm>
+          <a:prstGeom prst="rect">
             <a:avLst/>
           </a:prstGeom>
           <a:solidFill>
-            <a:srgbClr val="111C34"/>
+            <a:srgbClr val="047857"/>
           </a:solidFill>
-          <a:ln w="19050">
-            <a:solidFill>
-              <a:srgbClr val="10B981"/>
-            </a:solidFill>
+          <a:ln>
+            <a:noFill/>
           </a:ln>
         </p:spPr>
         <p:style>
@@ -5201,14 +5309,164 @@
       </p:sp>
       <p:sp>
         <p:nvSpPr>
-          <p:cNvPr id="7" name="TextBox 6"/>
+          <p:cNvPr id="4" name="TextBox 3"/>
           <p:cNvSpPr txBox="1"/>
           <p:nvPr/>
         </p:nvSpPr>
         <p:spPr>
           <a:xfrm>
+            <a:off x="731520" y="502920"/>
+            <a:ext cx="10698480" cy="320040"/>
+          </a:xfrm>
+          <a:prstGeom prst="rect">
+            <a:avLst/>
+          </a:prstGeom>
+          <a:noFill/>
+        </p:spPr>
+        <p:txBody>
+          <a:bodyPr wrap="none">
+            <a:spAutoFit/>
+          </a:bodyPr>
+          <a:lstStyle/>
+          <a:p>
+            <a:pPr>
+              <a:defRPr sz="1100" b="1">
+                <a:solidFill>
+                  <a:srgbClr val="047857"/>
+                </a:solidFill>
+              </a:defRPr>
+            </a:pPr>
+            <a:r>
+              <a:t>SLIDE 5  |  LIVESTOCK TRIAGE &amp; DIGITAL LEDGER</a:t>
+            </a:r>
+          </a:p>
+        </p:txBody>
+      </p:sp>
+      <p:sp>
+        <p:nvSpPr>
+          <p:cNvPr id="5" name="TextBox 4"/>
+          <p:cNvSpPr txBox="1"/>
+          <p:nvPr/>
+        </p:nvSpPr>
+        <p:spPr>
+          <a:xfrm>
+            <a:off x="731520" y="822960"/>
+            <a:ext cx="10698480" cy="685800"/>
+          </a:xfrm>
+          <a:prstGeom prst="rect">
+            <a:avLst/>
+          </a:prstGeom>
+          <a:noFill/>
+        </p:spPr>
+        <p:txBody>
+          <a:bodyPr wrap="none">
+            <a:spAutoFit/>
+          </a:bodyPr>
+          <a:lstStyle/>
+          <a:p>
+            <a:pPr>
+              <a:defRPr sz="2600" b="1">
+                <a:solidFill>
+                  <a:srgbClr val="065F46"/>
+                </a:solidFill>
+              </a:defRPr>
+            </a:pPr>
+            <a:r>
+              <a:t>Livestock Emergency Health Triage &amp; Ledger</a:t>
+            </a:r>
+          </a:p>
+        </p:txBody>
+      </p:sp>
+      <p:sp>
+        <p:nvSpPr>
+          <p:cNvPr id="6" name="TextBox 5"/>
+          <p:cNvSpPr txBox="1"/>
+          <p:nvPr/>
+        </p:nvSpPr>
+        <p:spPr>
+          <a:xfrm>
+            <a:off x="731520" y="1463040"/>
+            <a:ext cx="10698480" cy="411480"/>
+          </a:xfrm>
+          <a:prstGeom prst="rect">
+            <a:avLst/>
+          </a:prstGeom>
+          <a:noFill/>
+        </p:spPr>
+        <p:txBody>
+          <a:bodyPr wrap="none">
+            <a:spAutoFit/>
+          </a:bodyPr>
+          <a:lstStyle/>
+          <a:p>
+            <a:pPr>
+              <a:defRPr sz="1500" b="1">
+                <a:solidFill>
+                  <a:srgbClr val="0D9488"/>
+                </a:solidFill>
+              </a:defRPr>
+            </a:pPr>
+            <a:r>
+              <a:t>AIIMS Nursing Triage Protocol + 1-Click Sync to Digital Herd Ledger</a:t>
+            </a:r>
+          </a:p>
+        </p:txBody>
+      </p:sp>
+      <p:sp>
+        <p:nvSpPr>
+          <p:cNvPr id="7" name="Rounded Rectangle 6"/>
+          <p:cNvSpPr/>
+          <p:nvPr/>
+        </p:nvSpPr>
+        <p:spPr>
+          <a:xfrm>
+            <a:off x="731520" y="2011680"/>
+            <a:ext cx="5303520" cy="4206240"/>
+          </a:xfrm>
+          <a:prstGeom prst="roundRect">
+            <a:avLst/>
+          </a:prstGeom>
+          <a:solidFill>
+            <a:srgbClr val="F0FDF4"/>
+          </a:solidFill>
+          <a:ln w="19050">
+            <a:solidFill>
+              <a:srgbClr val="A7F3D0"/>
+            </a:solidFill>
+          </a:ln>
+        </p:spPr>
+        <p:style>
+          <a:lnRef idx="1">
+            <a:schemeClr val="accent1"/>
+          </a:lnRef>
+          <a:fillRef idx="3">
+            <a:schemeClr val="accent1"/>
+          </a:fillRef>
+          <a:effectRef idx="2">
+            <a:schemeClr val="accent1"/>
+          </a:effectRef>
+          <a:fontRef idx="minor">
+            <a:schemeClr val="lt1"/>
+          </a:fontRef>
+        </p:style>
+        <p:txBody>
+          <a:bodyPr rtlCol="0" anchor="ctr"/>
+          <a:lstStyle/>
+          <a:p>
+            <a:pPr algn="ctr"/>
+          </a:p>
+        </p:txBody>
+      </p:sp>
+      <p:sp>
+        <p:nvSpPr>
+          <p:cNvPr id="8" name="TextBox 7"/>
+          <p:cNvSpPr txBox="1"/>
+          <p:nvPr/>
+        </p:nvSpPr>
+        <p:spPr>
+          <a:xfrm>
             <a:off x="914400" y="2194560"/>
-            <a:ext cx="4937760" cy="3931920"/>
+            <a:ext cx="4937760" cy="3840480"/>
           </a:xfrm>
           <a:prstGeom prst="rect">
             <a:avLst/>
@@ -5223,79 +5481,79 @@
           <a:p>
             <a:pPr>
               <a:lnSpc>
-                <a:spcPct val="120000"/>
+                <a:spcPct val="125000"/>
               </a:lnSpc>
               <a:spcAft>
                 <a:spcPts val="1400"/>
               </a:spcAft>
               <a:defRPr sz="1400">
                 <a:solidFill>
-                  <a:srgbClr val="F3F4F6"/>
+                  <a:srgbClr val="1E293B"/>
                 </a:solidFill>
               </a:defRPr>
             </a:pPr>
             <a:r>
-              <a:t>• Animal Lesion &amp; Symptom Triage: Evaluates cattle, cow, buffalo, goat, &amp; poultry for FMD, Lumpy Skin, &amp; Mastitis.</a:t>
+              <a:t>✔  Animal Lesion &amp; Symptom Triage: Evaluates cattle, cow, buffalo, goat, &amp; poultry for FMD, Lumpy Skin, &amp; Mastitis.</a:t>
             </a:r>
           </a:p>
           <a:p>
             <a:pPr>
               <a:lnSpc>
-                <a:spcPct val="120000"/>
+                <a:spcPct val="125000"/>
               </a:lnSpc>
               <a:spcAft>
                 <a:spcPts val="1400"/>
               </a:spcAft>
               <a:defRPr sz="1400">
                 <a:solidFill>
-                  <a:srgbClr val="F3F4F6"/>
+                  <a:srgbClr val="1E293B"/>
                 </a:solidFill>
               </a:defRPr>
             </a:pPr>
             <a:r>
-              <a:t>• Emergency Action &amp; Vet SOS: Displays Tier-1 emergency steps &amp; direct call button for 1962 Helpline.</a:t>
+              <a:t>✔  Emergency Action &amp; Vet SOS: Displays Tier-1 emergency steps &amp; direct call button for 1962 Helpline.</a:t>
             </a:r>
           </a:p>
           <a:p>
             <a:pPr>
               <a:lnSpc>
-                <a:spcPct val="120000"/>
+                <a:spcPct val="125000"/>
               </a:lnSpc>
               <a:spcAft>
                 <a:spcPts val="1400"/>
               </a:spcAft>
               <a:defRPr sz="1400">
                 <a:solidFill>
-                  <a:srgbClr val="F3F4F6"/>
+                  <a:srgbClr val="1E293B"/>
                 </a:solidFill>
               </a:defRPr>
             </a:pPr>
             <a:r>
-              <a:t>• 1-Click Digital Ledger Sync: Automatically logs diagnoses and treatments into Farm &amp; Herd Ledger.</a:t>
-            </a:r>
-          </a:p>
-        </p:txBody>
-      </p:sp>
-      <p:sp>
-        <p:nvSpPr>
-          <p:cNvPr id="8" name="Rounded Rectangle 7"/>
+              <a:t>✔  1-Click Digital Ledger Sync: Automatically logs diagnoses and treatments into Farm &amp; Herd Ledger.</a:t>
+            </a:r>
+          </a:p>
+        </p:txBody>
+      </p:sp>
+      <p:sp>
+        <p:nvSpPr>
+          <p:cNvPr id="9" name="Rounded Rectangle 8"/>
           <p:cNvSpPr/>
           <p:nvPr/>
         </p:nvSpPr>
         <p:spPr>
           <a:xfrm>
-            <a:off x="6263640" y="1965960"/>
-            <a:ext cx="5212080" cy="4389120"/>
+            <a:off x="6302959" y="1975104"/>
+            <a:ext cx="5193792" cy="4279392"/>
           </a:xfrm>
           <a:prstGeom prst="roundRect">
             <a:avLst/>
           </a:prstGeom>
           <a:solidFill>
-            <a:srgbClr val="111C34"/>
+            <a:srgbClr val="FFFFFF"/>
           </a:solidFill>
           <a:ln w="25400">
             <a:solidFill>
-              <a:srgbClr val="10B981"/>
+              <a:srgbClr val="A7F3D0"/>
             </a:solidFill>
           </a:ln>
         </p:spPr>
@@ -5323,7 +5581,7 @@
       </p:sp>
       <p:pic>
         <p:nvPicPr>
-          <p:cNvPr id="9" name="Picture 8" descr="livestock_triage_1786640430124.png"/>
+          <p:cNvPr id="10" name="Picture 9" descr="livestock_triage_1786640430124.png"/>
           <p:cNvPicPr>
             <a:picLocks noChangeAspect="1"/>
           </p:cNvPicPr>
@@ -5337,8 +5595,8 @@
         </p:blipFill>
         <p:spPr>
           <a:xfrm>
-            <a:off x="6309360" y="2011680"/>
-            <a:ext cx="5120640" cy="4297680"/>
+            <a:off x="6339535" y="2011680"/>
+            <a:ext cx="5120640" cy="4206240"/>
           </a:xfrm>
           <a:prstGeom prst="rect">
             <a:avLst/>
@@ -5347,13 +5605,13 @@
       </p:pic>
       <p:sp>
         <p:nvSpPr>
-          <p:cNvPr id="10" name="TextBox 9"/>
+          <p:cNvPr id="11" name="TextBox 10"/>
           <p:cNvSpPr txBox="1"/>
           <p:nvPr/>
         </p:nvSpPr>
         <p:spPr>
           <a:xfrm>
-            <a:off x="731520" y="6400800"/>
+            <a:off x="731520" y="6355080"/>
             <a:ext cx="10698480" cy="274320"/>
           </a:xfrm>
           <a:prstGeom prst="rect">
@@ -5370,12 +5628,12 @@
             <a:pPr>
               <a:defRPr sz="1000">
                 <a:solidFill>
-                  <a:srgbClr val="9CA3AF"/>
+                  <a:srgbClr val="64748B"/>
                 </a:solidFill>
               </a:defRPr>
             </a:pPr>
             <a:r>
-              <a:t>AgriVision AI Platform | SIH 2026 Internal Hackathon | IIT Jodhpur &amp; AIIMS Jodhpur</a:t>
+              <a:t>AgriVision AI Platform  •  SIH 2026 Internal Hackathon  •  IIT Jodhpur &amp; AIIMS Jodhpur</a:t>
             </a:r>
           </a:p>
         </p:txBody>
@@ -5413,7 +5671,7 @@
             <a:avLst/>
           </a:prstGeom>
           <a:solidFill>
-            <a:srgbClr val="0B1426"/>
+            <a:srgbClr val="F8FAFC"/>
           </a:solidFill>
           <a:ln>
             <a:noFill/>
@@ -5443,130 +5701,23 @@
       </p:sp>
       <p:sp>
         <p:nvSpPr>
-          <p:cNvPr id="3" name="TextBox 2"/>
-          <p:cNvSpPr txBox="1"/>
-          <p:nvPr/>
-        </p:nvSpPr>
-        <p:spPr>
-          <a:xfrm>
-            <a:off x="731520" y="457200"/>
-            <a:ext cx="10698480" cy="365760"/>
-          </a:xfrm>
-          <a:prstGeom prst="rect">
-            <a:avLst/>
-          </a:prstGeom>
-          <a:noFill/>
-        </p:spPr>
-        <p:txBody>
-          <a:bodyPr wrap="none">
-            <a:spAutoFit/>
-          </a:bodyPr>
-          <a:lstStyle/>
-          <a:p>
-            <a:pPr>
-              <a:defRPr sz="1100" b="1">
-                <a:solidFill>
-                  <a:srgbClr val="10B981"/>
-                </a:solidFill>
-              </a:defRPr>
-            </a:pPr>
-            <a:r>
-              <a:t>SLIDE 6 | ACCESSIBILITY &amp; VOICE AI</a:t>
-            </a:r>
-          </a:p>
-        </p:txBody>
-      </p:sp>
-      <p:sp>
-        <p:nvSpPr>
-          <p:cNvPr id="4" name="TextBox 3"/>
-          <p:cNvSpPr txBox="1"/>
-          <p:nvPr/>
-        </p:nvSpPr>
-        <p:spPr>
-          <a:xfrm>
-            <a:off x="731520" y="777240"/>
-            <a:ext cx="10698480" cy="731520"/>
-          </a:xfrm>
-          <a:prstGeom prst="rect">
-            <a:avLst/>
-          </a:prstGeom>
-          <a:noFill/>
-        </p:spPr>
-        <p:txBody>
-          <a:bodyPr wrap="none">
-            <a:spAutoFit/>
-          </a:bodyPr>
-          <a:lstStyle/>
-          <a:p>
-            <a:pPr>
-              <a:defRPr sz="2600" b="1">
-                <a:solidFill>
-                  <a:srgbClr val="FFFFFF"/>
-                </a:solidFill>
-              </a:defRPr>
-            </a:pPr>
-            <a:r>
-              <a:t>Multilingual Audio Doctor &amp; Conversational AI</a:t>
-            </a:r>
-          </a:p>
-        </p:txBody>
-      </p:sp>
-      <p:sp>
-        <p:nvSpPr>
-          <p:cNvPr id="5" name="TextBox 4"/>
-          <p:cNvSpPr txBox="1"/>
-          <p:nvPr/>
-        </p:nvSpPr>
-        <p:spPr>
-          <a:xfrm>
-            <a:off x="731520" y="1371600"/>
-            <a:ext cx="10698480" cy="457200"/>
-          </a:xfrm>
-          <a:prstGeom prst="rect">
-            <a:avLst/>
-          </a:prstGeom>
-          <a:noFill/>
-        </p:spPr>
-        <p:txBody>
-          <a:bodyPr wrap="none">
-            <a:spAutoFit/>
-          </a:bodyPr>
-          <a:lstStyle/>
-          <a:p>
-            <a:pPr>
-              <a:defRPr sz="1500" b="1">
-                <a:solidFill>
-                  <a:srgbClr val="34D399"/>
-                </a:solidFill>
-              </a:defRPr>
-            </a:pPr>
-            <a:r>
-              <a:t>Natural Voice Assistance in Hindi, English, and Marwari</a:t>
-            </a:r>
-          </a:p>
-        </p:txBody>
-      </p:sp>
-      <p:sp>
-        <p:nvSpPr>
-          <p:cNvPr id="6" name="Rounded Rectangle 5"/>
+          <p:cNvPr id="3" name="Rectangle 2"/>
           <p:cNvSpPr/>
           <p:nvPr/>
         </p:nvSpPr>
         <p:spPr>
           <a:xfrm>
-            <a:off x="731520" y="2011680"/>
-            <a:ext cx="5303520" cy="4297680"/>
-          </a:xfrm>
-          <a:prstGeom prst="roundRect">
+            <a:off x="731520" y="365760"/>
+            <a:ext cx="10728655" cy="54864"/>
+          </a:xfrm>
+          <a:prstGeom prst="rect">
             <a:avLst/>
           </a:prstGeom>
           <a:solidFill>
-            <a:srgbClr val="111C34"/>
+            <a:srgbClr val="047857"/>
           </a:solidFill>
-          <a:ln w="19050">
-            <a:solidFill>
-              <a:srgbClr val="10B981"/>
-            </a:solidFill>
+          <a:ln>
+            <a:noFill/>
           </a:ln>
         </p:spPr>
         <p:style>
@@ -5593,14 +5744,164 @@
       </p:sp>
       <p:sp>
         <p:nvSpPr>
-          <p:cNvPr id="7" name="TextBox 6"/>
+          <p:cNvPr id="4" name="TextBox 3"/>
           <p:cNvSpPr txBox="1"/>
           <p:nvPr/>
         </p:nvSpPr>
         <p:spPr>
           <a:xfrm>
+            <a:off x="731520" y="502920"/>
+            <a:ext cx="10698480" cy="320040"/>
+          </a:xfrm>
+          <a:prstGeom prst="rect">
+            <a:avLst/>
+          </a:prstGeom>
+          <a:noFill/>
+        </p:spPr>
+        <p:txBody>
+          <a:bodyPr wrap="none">
+            <a:spAutoFit/>
+          </a:bodyPr>
+          <a:lstStyle/>
+          <a:p>
+            <a:pPr>
+              <a:defRPr sz="1100" b="1">
+                <a:solidFill>
+                  <a:srgbClr val="047857"/>
+                </a:solidFill>
+              </a:defRPr>
+            </a:pPr>
+            <a:r>
+              <a:t>SLIDE 6  |  ACCESSIBILITY &amp; VOICE AI</a:t>
+            </a:r>
+          </a:p>
+        </p:txBody>
+      </p:sp>
+      <p:sp>
+        <p:nvSpPr>
+          <p:cNvPr id="5" name="TextBox 4"/>
+          <p:cNvSpPr txBox="1"/>
+          <p:nvPr/>
+        </p:nvSpPr>
+        <p:spPr>
+          <a:xfrm>
+            <a:off x="731520" y="822960"/>
+            <a:ext cx="10698480" cy="685800"/>
+          </a:xfrm>
+          <a:prstGeom prst="rect">
+            <a:avLst/>
+          </a:prstGeom>
+          <a:noFill/>
+        </p:spPr>
+        <p:txBody>
+          <a:bodyPr wrap="none">
+            <a:spAutoFit/>
+          </a:bodyPr>
+          <a:lstStyle/>
+          <a:p>
+            <a:pPr>
+              <a:defRPr sz="2600" b="1">
+                <a:solidFill>
+                  <a:srgbClr val="065F46"/>
+                </a:solidFill>
+              </a:defRPr>
+            </a:pPr>
+            <a:r>
+              <a:t>Multilingual Audio Doctor &amp; Conversational AI</a:t>
+            </a:r>
+          </a:p>
+        </p:txBody>
+      </p:sp>
+      <p:sp>
+        <p:nvSpPr>
+          <p:cNvPr id="6" name="TextBox 5"/>
+          <p:cNvSpPr txBox="1"/>
+          <p:nvPr/>
+        </p:nvSpPr>
+        <p:spPr>
+          <a:xfrm>
+            <a:off x="731520" y="1463040"/>
+            <a:ext cx="10698480" cy="411480"/>
+          </a:xfrm>
+          <a:prstGeom prst="rect">
+            <a:avLst/>
+          </a:prstGeom>
+          <a:noFill/>
+        </p:spPr>
+        <p:txBody>
+          <a:bodyPr wrap="none">
+            <a:spAutoFit/>
+          </a:bodyPr>
+          <a:lstStyle/>
+          <a:p>
+            <a:pPr>
+              <a:defRPr sz="1500" b="1">
+                <a:solidFill>
+                  <a:srgbClr val="0D9488"/>
+                </a:solidFill>
+              </a:defRPr>
+            </a:pPr>
+            <a:r>
+              <a:t>Natural Voice Assistance in Hindi, English, and Marwari</a:t>
+            </a:r>
+          </a:p>
+        </p:txBody>
+      </p:sp>
+      <p:sp>
+        <p:nvSpPr>
+          <p:cNvPr id="7" name="Rounded Rectangle 6"/>
+          <p:cNvSpPr/>
+          <p:nvPr/>
+        </p:nvSpPr>
+        <p:spPr>
+          <a:xfrm>
+            <a:off x="731520" y="2011680"/>
+            <a:ext cx="5303520" cy="4206240"/>
+          </a:xfrm>
+          <a:prstGeom prst="roundRect">
+            <a:avLst/>
+          </a:prstGeom>
+          <a:solidFill>
+            <a:srgbClr val="F0FDF4"/>
+          </a:solidFill>
+          <a:ln w="19050">
+            <a:solidFill>
+              <a:srgbClr val="A7F3D0"/>
+            </a:solidFill>
+          </a:ln>
+        </p:spPr>
+        <p:style>
+          <a:lnRef idx="1">
+            <a:schemeClr val="accent1"/>
+          </a:lnRef>
+          <a:fillRef idx="3">
+            <a:schemeClr val="accent1"/>
+          </a:fillRef>
+          <a:effectRef idx="2">
+            <a:schemeClr val="accent1"/>
+          </a:effectRef>
+          <a:fontRef idx="minor">
+            <a:schemeClr val="lt1"/>
+          </a:fontRef>
+        </p:style>
+        <p:txBody>
+          <a:bodyPr rtlCol="0" anchor="ctr"/>
+          <a:lstStyle/>
+          <a:p>
+            <a:pPr algn="ctr"/>
+          </a:p>
+        </p:txBody>
+      </p:sp>
+      <p:sp>
+        <p:nvSpPr>
+          <p:cNvPr id="8" name="TextBox 7"/>
+          <p:cNvSpPr txBox="1"/>
+          <p:nvPr/>
+        </p:nvSpPr>
+        <p:spPr>
+          <a:xfrm>
             <a:off x="914400" y="2194560"/>
-            <a:ext cx="4937760" cy="3931920"/>
+            <a:ext cx="4937760" cy="3840480"/>
           </a:xfrm>
           <a:prstGeom prst="rect">
             <a:avLst/>
@@ -5615,79 +5916,79 @@
           <a:p>
             <a:pPr>
               <a:lnSpc>
-                <a:spcPct val="120000"/>
+                <a:spcPct val="125000"/>
               </a:lnSpc>
               <a:spcAft>
                 <a:spcPts val="1400"/>
               </a:spcAft>
               <a:defRPr sz="1400">
                 <a:solidFill>
-                  <a:srgbClr val="F3F4F6"/>
+                  <a:srgbClr val="1E293B"/>
                 </a:solidFill>
               </a:defRPr>
             </a:pPr>
             <a:r>
-              <a:t>• Conversational Text-To-Speech: Reads out treatment protocols in natural Hindi, English, &amp; Marwari.</a:t>
+              <a:t>✔  Conversational Text-To-Speech: Reads out treatment protocols in natural Hindi, English, &amp; Marwari.</a:t>
             </a:r>
           </a:p>
           <a:p>
             <a:pPr>
               <a:lnSpc>
-                <a:spcPct val="120000"/>
+                <a:spcPct val="125000"/>
               </a:lnSpc>
               <a:spcAft>
                 <a:spcPts val="1400"/>
               </a:spcAft>
               <a:defRPr sz="1400">
                 <a:solidFill>
-                  <a:srgbClr val="F3F4F6"/>
+                  <a:srgbClr val="1E293B"/>
                 </a:solidFill>
               </a:defRPr>
             </a:pPr>
             <a:r>
-              <a:t>• Smart Intent Chatbot: Responds intelligently to Hinglish queries ('meri gaay chara nahi kha rahi he', 'chhale/laar').</a:t>
+              <a:t>✔  Smart Intent Chatbot: Responds intelligently to Hinglish queries ('meri gaay chara nahi kha rahi he', 'chhale/laar').</a:t>
             </a:r>
           </a:p>
           <a:p>
             <a:pPr>
               <a:lnSpc>
-                <a:spcPct val="120000"/>
+                <a:spcPct val="125000"/>
               </a:lnSpc>
               <a:spcAft>
                 <a:spcPts val="1400"/>
               </a:spcAft>
               <a:defRPr sz="1400">
                 <a:solidFill>
-                  <a:srgbClr val="F3F4F6"/>
+                  <a:srgbClr val="1E293B"/>
                 </a:solidFill>
               </a:defRPr>
             </a:pPr>
             <a:r>
-              <a:t>• A4 PDF Official Certificate: Generates downloadable single-page official diagnostic reports with seal.</a:t>
-            </a:r>
-          </a:p>
-        </p:txBody>
-      </p:sp>
-      <p:sp>
-        <p:nvSpPr>
-          <p:cNvPr id="8" name="Rounded Rectangle 7"/>
+              <a:t>✔  A4 PDF Official Certificate: Generates downloadable single-page official diagnostic reports with seal.</a:t>
+            </a:r>
+          </a:p>
+        </p:txBody>
+      </p:sp>
+      <p:sp>
+        <p:nvSpPr>
+          <p:cNvPr id="9" name="Rounded Rectangle 8"/>
           <p:cNvSpPr/>
           <p:nvPr/>
         </p:nvSpPr>
         <p:spPr>
           <a:xfrm>
-            <a:off x="6263640" y="1965960"/>
-            <a:ext cx="5212080" cy="4389120"/>
+            <a:off x="6302959" y="1975104"/>
+            <a:ext cx="5193792" cy="4279392"/>
           </a:xfrm>
           <a:prstGeom prst="roundRect">
             <a:avLst/>
           </a:prstGeom>
           <a:solidFill>
-            <a:srgbClr val="111C34"/>
+            <a:srgbClr val="FFFFFF"/>
           </a:solidFill>
           <a:ln w="25400">
             <a:solidFill>
-              <a:srgbClr val="10B981"/>
+              <a:srgbClr val="A7F3D0"/>
             </a:solidFill>
           </a:ln>
         </p:spPr>
@@ -5715,7 +6016,7 @@
       </p:sp>
       <p:pic>
         <p:nvPicPr>
-          <p:cNvPr id="9" name="Picture 8" descr="advisory_alerts_1786640449172.png"/>
+          <p:cNvPr id="10" name="Picture 9" descr="advisory_alerts_1786640449172.png"/>
           <p:cNvPicPr>
             <a:picLocks noChangeAspect="1"/>
           </p:cNvPicPr>
@@ -5729,8 +6030,8 @@
         </p:blipFill>
         <p:spPr>
           <a:xfrm>
-            <a:off x="6309360" y="2011680"/>
-            <a:ext cx="5120640" cy="4297680"/>
+            <a:off x="6339535" y="2011680"/>
+            <a:ext cx="5120640" cy="4206240"/>
           </a:xfrm>
           <a:prstGeom prst="rect">
             <a:avLst/>
@@ -5739,13 +6040,13 @@
       </p:pic>
       <p:sp>
         <p:nvSpPr>
-          <p:cNvPr id="10" name="TextBox 9"/>
+          <p:cNvPr id="11" name="TextBox 10"/>
           <p:cNvSpPr txBox="1"/>
           <p:nvPr/>
         </p:nvSpPr>
         <p:spPr>
           <a:xfrm>
-            <a:off x="731520" y="6400800"/>
+            <a:off x="731520" y="6355080"/>
             <a:ext cx="10698480" cy="274320"/>
           </a:xfrm>
           <a:prstGeom prst="rect">
@@ -5762,12 +6063,12 @@
             <a:pPr>
               <a:defRPr sz="1000">
                 <a:solidFill>
-                  <a:srgbClr val="9CA3AF"/>
+                  <a:srgbClr val="64748B"/>
                 </a:solidFill>
               </a:defRPr>
             </a:pPr>
             <a:r>
-              <a:t>AgriVision AI Platform | SIH 2026 Internal Hackathon | IIT Jodhpur &amp; AIIMS Jodhpur</a:t>
+              <a:t>AgriVision AI Platform  •  SIH 2026 Internal Hackathon  •  IIT Jodhpur &amp; AIIMS Jodhpur</a:t>
             </a:r>
           </a:p>
         </p:txBody>
@@ -5805,7 +6106,7 @@
             <a:avLst/>
           </a:prstGeom>
           <a:solidFill>
-            <a:srgbClr val="0B1426"/>
+            <a:srgbClr val="F8FAFC"/>
           </a:solidFill>
           <a:ln>
             <a:noFill/>
@@ -5835,130 +6136,23 @@
       </p:sp>
       <p:sp>
         <p:nvSpPr>
-          <p:cNvPr id="3" name="TextBox 2"/>
-          <p:cNvSpPr txBox="1"/>
-          <p:nvPr/>
-        </p:nvSpPr>
-        <p:spPr>
-          <a:xfrm>
-            <a:off x="731520" y="457200"/>
-            <a:ext cx="10698480" cy="365760"/>
-          </a:xfrm>
-          <a:prstGeom prst="rect">
-            <a:avLst/>
-          </a:prstGeom>
-          <a:noFill/>
-        </p:spPr>
-        <p:txBody>
-          <a:bodyPr wrap="none">
-            <a:spAutoFit/>
-          </a:bodyPr>
-          <a:lstStyle/>
-          <a:p>
-            <a:pPr>
-              <a:defRPr sz="1100" b="1">
-                <a:solidFill>
-                  <a:srgbClr val="10B981"/>
-                </a:solidFill>
-              </a:defRPr>
-            </a:pPr>
-            <a:r>
-              <a:t>SLIDE 7 | COMPETITIVE EDGE</a:t>
-            </a:r>
-          </a:p>
-        </p:txBody>
-      </p:sp>
-      <p:sp>
-        <p:nvSpPr>
-          <p:cNvPr id="4" name="TextBox 3"/>
-          <p:cNvSpPr txBox="1"/>
-          <p:nvPr/>
-        </p:nvSpPr>
-        <p:spPr>
-          <a:xfrm>
-            <a:off x="731520" y="777240"/>
-            <a:ext cx="10698480" cy="731520"/>
-          </a:xfrm>
-          <a:prstGeom prst="rect">
-            <a:avLst/>
-          </a:prstGeom>
-          <a:noFill/>
-        </p:spPr>
-        <p:txBody>
-          <a:bodyPr wrap="none">
-            <a:spAutoFit/>
-          </a:bodyPr>
-          <a:lstStyle/>
-          <a:p>
-            <a:pPr>
-              <a:defRPr sz="2600" b="1">
-                <a:solidFill>
-                  <a:srgbClr val="FFFFFF"/>
-                </a:solidFill>
-              </a:defRPr>
-            </a:pPr>
-            <a:r>
-              <a:t>Clinical Rigor Applied to Agriculture</a:t>
-            </a:r>
-          </a:p>
-        </p:txBody>
-      </p:sp>
-      <p:sp>
-        <p:nvSpPr>
-          <p:cNvPr id="5" name="TextBox 4"/>
-          <p:cNvSpPr txBox="1"/>
-          <p:nvPr/>
-        </p:nvSpPr>
-        <p:spPr>
-          <a:xfrm>
-            <a:off x="731520" y="1371600"/>
-            <a:ext cx="10698480" cy="457200"/>
-          </a:xfrm>
-          <a:prstGeom prst="rect">
-            <a:avLst/>
-          </a:prstGeom>
-          <a:noFill/>
-        </p:spPr>
-        <p:txBody>
-          <a:bodyPr wrap="none">
-            <a:spAutoFit/>
-          </a:bodyPr>
-          <a:lstStyle/>
-          <a:p>
-            <a:pPr>
-              <a:defRPr sz="1500" b="1">
-                <a:solidFill>
-                  <a:srgbClr val="34D399"/>
-                </a:solidFill>
-              </a:defRPr>
-            </a:pPr>
-            <a:r>
-              <a:t>Unique Competitive Advantage of AIIMS &amp; IIT Jodhpur Leadership</a:t>
-            </a:r>
-          </a:p>
-        </p:txBody>
-      </p:sp>
-      <p:sp>
-        <p:nvSpPr>
-          <p:cNvPr id="6" name="Rounded Rectangle 5"/>
+          <p:cNvPr id="3" name="Rectangle 2"/>
           <p:cNvSpPr/>
           <p:nvPr/>
         </p:nvSpPr>
         <p:spPr>
           <a:xfrm>
-            <a:off x="731520" y="2011680"/>
-            <a:ext cx="5303520" cy="4297680"/>
-          </a:xfrm>
-          <a:prstGeom prst="roundRect">
+            <a:off x="731520" y="365760"/>
+            <a:ext cx="10728655" cy="54864"/>
+          </a:xfrm>
+          <a:prstGeom prst="rect">
             <a:avLst/>
           </a:prstGeom>
           <a:solidFill>
-            <a:srgbClr val="111C34"/>
+            <a:srgbClr val="047857"/>
           </a:solidFill>
-          <a:ln w="19050">
-            <a:solidFill>
-              <a:srgbClr val="10B981"/>
-            </a:solidFill>
+          <a:ln>
+            <a:noFill/>
           </a:ln>
         </p:spPr>
         <p:style>
@@ -5985,14 +6179,164 @@
       </p:sp>
       <p:sp>
         <p:nvSpPr>
-          <p:cNvPr id="7" name="TextBox 6"/>
+          <p:cNvPr id="4" name="TextBox 3"/>
           <p:cNvSpPr txBox="1"/>
           <p:nvPr/>
         </p:nvSpPr>
         <p:spPr>
           <a:xfrm>
+            <a:off x="731520" y="502920"/>
+            <a:ext cx="10698480" cy="320040"/>
+          </a:xfrm>
+          <a:prstGeom prst="rect">
+            <a:avLst/>
+          </a:prstGeom>
+          <a:noFill/>
+        </p:spPr>
+        <p:txBody>
+          <a:bodyPr wrap="none">
+            <a:spAutoFit/>
+          </a:bodyPr>
+          <a:lstStyle/>
+          <a:p>
+            <a:pPr>
+              <a:defRPr sz="1100" b="1">
+                <a:solidFill>
+                  <a:srgbClr val="047857"/>
+                </a:solidFill>
+              </a:defRPr>
+            </a:pPr>
+            <a:r>
+              <a:t>SLIDE 7  |  COMPETITIVE EDGE</a:t>
+            </a:r>
+          </a:p>
+        </p:txBody>
+      </p:sp>
+      <p:sp>
+        <p:nvSpPr>
+          <p:cNvPr id="5" name="TextBox 4"/>
+          <p:cNvSpPr txBox="1"/>
+          <p:nvPr/>
+        </p:nvSpPr>
+        <p:spPr>
+          <a:xfrm>
+            <a:off x="731520" y="822960"/>
+            <a:ext cx="10698480" cy="685800"/>
+          </a:xfrm>
+          <a:prstGeom prst="rect">
+            <a:avLst/>
+          </a:prstGeom>
+          <a:noFill/>
+        </p:spPr>
+        <p:txBody>
+          <a:bodyPr wrap="none">
+            <a:spAutoFit/>
+          </a:bodyPr>
+          <a:lstStyle/>
+          <a:p>
+            <a:pPr>
+              <a:defRPr sz="2600" b="1">
+                <a:solidFill>
+                  <a:srgbClr val="065F46"/>
+                </a:solidFill>
+              </a:defRPr>
+            </a:pPr>
+            <a:r>
+              <a:t>Clinical Rigor Applied to Agriculture</a:t>
+            </a:r>
+          </a:p>
+        </p:txBody>
+      </p:sp>
+      <p:sp>
+        <p:nvSpPr>
+          <p:cNvPr id="6" name="TextBox 5"/>
+          <p:cNvSpPr txBox="1"/>
+          <p:nvPr/>
+        </p:nvSpPr>
+        <p:spPr>
+          <a:xfrm>
+            <a:off x="731520" y="1463040"/>
+            <a:ext cx="10698480" cy="411480"/>
+          </a:xfrm>
+          <a:prstGeom prst="rect">
+            <a:avLst/>
+          </a:prstGeom>
+          <a:noFill/>
+        </p:spPr>
+        <p:txBody>
+          <a:bodyPr wrap="none">
+            <a:spAutoFit/>
+          </a:bodyPr>
+          <a:lstStyle/>
+          <a:p>
+            <a:pPr>
+              <a:defRPr sz="1500" b="1">
+                <a:solidFill>
+                  <a:srgbClr val="0D9488"/>
+                </a:solidFill>
+              </a:defRPr>
+            </a:pPr>
+            <a:r>
+              <a:t>Unique Competitive Advantage of AIIMS &amp; IIT Jodhpur Leadership</a:t>
+            </a:r>
+          </a:p>
+        </p:txBody>
+      </p:sp>
+      <p:sp>
+        <p:nvSpPr>
+          <p:cNvPr id="7" name="Rounded Rectangle 6"/>
+          <p:cNvSpPr/>
+          <p:nvPr/>
+        </p:nvSpPr>
+        <p:spPr>
+          <a:xfrm>
+            <a:off x="731520" y="2011680"/>
+            <a:ext cx="5303520" cy="4206240"/>
+          </a:xfrm>
+          <a:prstGeom prst="roundRect">
+            <a:avLst/>
+          </a:prstGeom>
+          <a:solidFill>
+            <a:srgbClr val="F0FDF4"/>
+          </a:solidFill>
+          <a:ln w="19050">
+            <a:solidFill>
+              <a:srgbClr val="A7F3D0"/>
+            </a:solidFill>
+          </a:ln>
+        </p:spPr>
+        <p:style>
+          <a:lnRef idx="1">
+            <a:schemeClr val="accent1"/>
+          </a:lnRef>
+          <a:fillRef idx="3">
+            <a:schemeClr val="accent1"/>
+          </a:fillRef>
+          <a:effectRef idx="2">
+            <a:schemeClr val="accent1"/>
+          </a:effectRef>
+          <a:fontRef idx="minor">
+            <a:schemeClr val="lt1"/>
+          </a:fontRef>
+        </p:style>
+        <p:txBody>
+          <a:bodyPr rtlCol="0" anchor="ctr"/>
+          <a:lstStyle/>
+          <a:p>
+            <a:pPr algn="ctr"/>
+          </a:p>
+        </p:txBody>
+      </p:sp>
+      <p:sp>
+        <p:nvSpPr>
+          <p:cNvPr id="8" name="TextBox 7"/>
+          <p:cNvSpPr txBox="1"/>
+          <p:nvPr/>
+        </p:nvSpPr>
+        <p:spPr>
+          <a:xfrm>
             <a:off x="914400" y="2194560"/>
-            <a:ext cx="4937760" cy="3931920"/>
+            <a:ext cx="4937760" cy="3840480"/>
           </a:xfrm>
           <a:prstGeom prst="rect">
             <a:avLst/>
@@ -6007,79 +6351,79 @@
           <a:p>
             <a:pPr>
               <a:lnSpc>
-                <a:spcPct val="120000"/>
+                <a:spcPct val="125000"/>
               </a:lnSpc>
               <a:spcAft>
                 <a:spcPts val="1400"/>
               </a:spcAft>
               <a:defRPr sz="1400">
                 <a:solidFill>
-                  <a:srgbClr val="F3F4F6"/>
+                  <a:srgbClr val="1E293B"/>
                 </a:solidFill>
               </a:defRPr>
             </a:pPr>
             <a:r>
-              <a:t>• Medical Triage Precision: Clinical diagnostic workflows applied directly to animal &amp; crop pathology.</a:t>
+              <a:t>✔  Medical Triage Precision: Clinical diagnostic workflows applied directly to animal &amp; crop pathology.</a:t>
             </a:r>
           </a:p>
           <a:p>
             <a:pPr>
               <a:lnSpc>
-                <a:spcPct val="120000"/>
+                <a:spcPct val="125000"/>
               </a:lnSpc>
               <a:spcAft>
                 <a:spcPts val="1400"/>
               </a:spcAft>
               <a:defRPr sz="1400">
                 <a:solidFill>
-                  <a:srgbClr val="F3F4F6"/>
+                  <a:srgbClr val="1E293B"/>
                 </a:solidFill>
               </a:defRPr>
             </a:pPr>
             <a:r>
-              <a:t>• Zero False-Negative Goal: Minimizes diagnostic errors in critical infectious outbreaks.</a:t>
+              <a:t>✔  Zero False-Negative Goal: Minimizes diagnostic errors in critical infectious outbreaks.</a:t>
             </a:r>
           </a:p>
           <a:p>
             <a:pPr>
               <a:lnSpc>
-                <a:spcPct val="120000"/>
+                <a:spcPct val="125000"/>
               </a:lnSpc>
               <a:spcAft>
                 <a:spcPts val="1400"/>
               </a:spcAft>
               <a:defRPr sz="1400">
                 <a:solidFill>
-                  <a:srgbClr val="F3F4F6"/>
+                  <a:srgbClr val="1E293B"/>
                 </a:solidFill>
               </a:defRPr>
             </a:pPr>
             <a:r>
-              <a:t>• Rural-First UX Design: High-contrast dark mode, large touch targets, and low-bandwidth 2G mode support.</a:t>
-            </a:r>
-          </a:p>
-        </p:txBody>
-      </p:sp>
-      <p:sp>
-        <p:nvSpPr>
-          <p:cNvPr id="8" name="Rounded Rectangle 7"/>
+              <a:t>✔  Rural-First UX Design: High-contrast responsive design, large touch targets, and low-bandwidth 2G mode support.</a:t>
+            </a:r>
+          </a:p>
+        </p:txBody>
+      </p:sp>
+      <p:sp>
+        <p:nvSpPr>
+          <p:cNvPr id="9" name="Rounded Rectangle 8"/>
           <p:cNvSpPr/>
           <p:nvPr/>
         </p:nvSpPr>
         <p:spPr>
           <a:xfrm>
-            <a:off x="6263640" y="1965960"/>
-            <a:ext cx="5212080" cy="4389120"/>
+            <a:off x="6302959" y="1975104"/>
+            <a:ext cx="5193792" cy="4279392"/>
           </a:xfrm>
           <a:prstGeom prst="roundRect">
             <a:avLst/>
           </a:prstGeom>
           <a:solidFill>
-            <a:srgbClr val="111C34"/>
+            <a:srgbClr val="FFFFFF"/>
           </a:solidFill>
           <a:ln w="25400">
             <a:solidFill>
-              <a:srgbClr val="10B981"/>
+              <a:srgbClr val="A7F3D0"/>
             </a:solidFill>
           </a:ln>
         </p:spPr>
@@ -6107,7 +6451,7 @@
       </p:sp>
       <p:pic>
         <p:nvPicPr>
-          <p:cNvPr id="9" name="Picture 8" descr="farm_ledger_1786640439309.png"/>
+          <p:cNvPr id="10" name="Picture 9" descr="farm_ledger_1786640439309.png"/>
           <p:cNvPicPr>
             <a:picLocks noChangeAspect="1"/>
           </p:cNvPicPr>
@@ -6121,8 +6465,8 @@
         </p:blipFill>
         <p:spPr>
           <a:xfrm>
-            <a:off x="6309360" y="2011680"/>
-            <a:ext cx="5120640" cy="4297680"/>
+            <a:off x="6339535" y="2011680"/>
+            <a:ext cx="5120640" cy="4206240"/>
           </a:xfrm>
           <a:prstGeom prst="rect">
             <a:avLst/>
@@ -6131,13 +6475,13 @@
       </p:pic>
       <p:sp>
         <p:nvSpPr>
-          <p:cNvPr id="10" name="TextBox 9"/>
+          <p:cNvPr id="11" name="TextBox 10"/>
           <p:cNvSpPr txBox="1"/>
           <p:nvPr/>
         </p:nvSpPr>
         <p:spPr>
           <a:xfrm>
-            <a:off x="731520" y="6400800"/>
+            <a:off x="731520" y="6355080"/>
             <a:ext cx="10698480" cy="274320"/>
           </a:xfrm>
           <a:prstGeom prst="rect">
@@ -6154,12 +6498,12 @@
             <a:pPr>
               <a:defRPr sz="1000">
                 <a:solidFill>
-                  <a:srgbClr val="9CA3AF"/>
+                  <a:srgbClr val="64748B"/>
                 </a:solidFill>
               </a:defRPr>
             </a:pPr>
             <a:r>
-              <a:t>AgriVision AI Platform | SIH 2026 Internal Hackathon | IIT Jodhpur &amp; AIIMS Jodhpur</a:t>
+              <a:t>AgriVision AI Platform  •  SIH 2026 Internal Hackathon  •  IIT Jodhpur &amp; AIIMS Jodhpur</a:t>
             </a:r>
           </a:p>
         </p:txBody>
@@ -6197,7 +6541,7 @@
             <a:avLst/>
           </a:prstGeom>
           <a:solidFill>
-            <a:srgbClr val="0B1426"/>
+            <a:srgbClr val="F8FAFC"/>
           </a:solidFill>
           <a:ln>
             <a:noFill/>
@@ -6227,130 +6571,23 @@
       </p:sp>
       <p:sp>
         <p:nvSpPr>
-          <p:cNvPr id="3" name="TextBox 2"/>
-          <p:cNvSpPr txBox="1"/>
-          <p:nvPr/>
-        </p:nvSpPr>
-        <p:spPr>
-          <a:xfrm>
-            <a:off x="731520" y="457200"/>
-            <a:ext cx="10698480" cy="365760"/>
-          </a:xfrm>
-          <a:prstGeom prst="rect">
-            <a:avLst/>
-          </a:prstGeom>
-          <a:noFill/>
-        </p:spPr>
-        <p:txBody>
-          <a:bodyPr wrap="none">
-            <a:spAutoFit/>
-          </a:bodyPr>
-          <a:lstStyle/>
-          <a:p>
-            <a:pPr>
-              <a:defRPr sz="1100" b="1">
-                <a:solidFill>
-                  <a:srgbClr val="10B981"/>
-                </a:solidFill>
-              </a:defRPr>
-            </a:pPr>
-            <a:r>
-              <a:t>SLIDE 8 | EPIDEMIC SURVEILLANCE</a:t>
-            </a:r>
-          </a:p>
-        </p:txBody>
-      </p:sp>
-      <p:sp>
-        <p:nvSpPr>
-          <p:cNvPr id="4" name="TextBox 3"/>
-          <p:cNvSpPr txBox="1"/>
-          <p:nvPr/>
-        </p:nvSpPr>
-        <p:spPr>
-          <a:xfrm>
-            <a:off x="731520" y="777240"/>
-            <a:ext cx="10698480" cy="731520"/>
-          </a:xfrm>
-          <a:prstGeom prst="rect">
-            <a:avLst/>
-          </a:prstGeom>
-          <a:noFill/>
-        </p:spPr>
-        <p:txBody>
-          <a:bodyPr wrap="none">
-            <a:spAutoFit/>
-          </a:bodyPr>
-          <a:lstStyle/>
-          <a:p>
-            <a:pPr>
-              <a:defRPr sz="2600" b="1">
-                <a:solidFill>
-                  <a:srgbClr val="FFFFFF"/>
-                </a:solidFill>
-              </a:defRPr>
-            </a:pPr>
-            <a:r>
-              <a:t>GIS Outbreak Radar &amp; KVK Early Warning Network</a:t>
-            </a:r>
-          </a:p>
-        </p:txBody>
-      </p:sp>
-      <p:sp>
-        <p:nvSpPr>
-          <p:cNvPr id="5" name="TextBox 4"/>
-          <p:cNvSpPr txBox="1"/>
-          <p:nvPr/>
-        </p:nvSpPr>
-        <p:spPr>
-          <a:xfrm>
-            <a:off x="731520" y="1371600"/>
-            <a:ext cx="10698480" cy="457200"/>
-          </a:xfrm>
-          <a:prstGeom prst="rect">
-            <a:avLst/>
-          </a:prstGeom>
-          <a:noFill/>
-        </p:spPr>
-        <p:txBody>
-          <a:bodyPr wrap="none">
-            <a:spAutoFit/>
-          </a:bodyPr>
-          <a:lstStyle/>
-          <a:p>
-            <a:pPr>
-              <a:defRPr sz="1500" b="1">
-                <a:solidFill>
-                  <a:srgbClr val="34D399"/>
-                </a:solidFill>
-              </a:defRPr>
-            </a:pPr>
-            <a:r>
-              <a:t>Epidemic Surveillance &amp; Proactive Outbreak Containment</a:t>
-            </a:r>
-          </a:p>
-        </p:txBody>
-      </p:sp>
-      <p:sp>
-        <p:nvSpPr>
-          <p:cNvPr id="6" name="Rounded Rectangle 5"/>
+          <p:cNvPr id="3" name="Rectangle 2"/>
           <p:cNvSpPr/>
           <p:nvPr/>
         </p:nvSpPr>
         <p:spPr>
           <a:xfrm>
-            <a:off x="731520" y="2011680"/>
-            <a:ext cx="5303520" cy="4297680"/>
-          </a:xfrm>
-          <a:prstGeom prst="roundRect">
+            <a:off x="731520" y="365760"/>
+            <a:ext cx="10728655" cy="54864"/>
+          </a:xfrm>
+          <a:prstGeom prst="rect">
             <a:avLst/>
           </a:prstGeom>
           <a:solidFill>
-            <a:srgbClr val="111C34"/>
+            <a:srgbClr val="047857"/>
           </a:solidFill>
-          <a:ln w="19050">
-            <a:solidFill>
-              <a:srgbClr val="10B981"/>
-            </a:solidFill>
+          <a:ln>
+            <a:noFill/>
           </a:ln>
         </p:spPr>
         <p:style>
@@ -6377,14 +6614,164 @@
       </p:sp>
       <p:sp>
         <p:nvSpPr>
-          <p:cNvPr id="7" name="TextBox 6"/>
+          <p:cNvPr id="4" name="TextBox 3"/>
           <p:cNvSpPr txBox="1"/>
           <p:nvPr/>
         </p:nvSpPr>
         <p:spPr>
           <a:xfrm>
+            <a:off x="731520" y="502920"/>
+            <a:ext cx="10698480" cy="320040"/>
+          </a:xfrm>
+          <a:prstGeom prst="rect">
+            <a:avLst/>
+          </a:prstGeom>
+          <a:noFill/>
+        </p:spPr>
+        <p:txBody>
+          <a:bodyPr wrap="none">
+            <a:spAutoFit/>
+          </a:bodyPr>
+          <a:lstStyle/>
+          <a:p>
+            <a:pPr>
+              <a:defRPr sz="1100" b="1">
+                <a:solidFill>
+                  <a:srgbClr val="047857"/>
+                </a:solidFill>
+              </a:defRPr>
+            </a:pPr>
+            <a:r>
+              <a:t>SLIDE 8  |  EPIDEMIC SURVEILLANCE</a:t>
+            </a:r>
+          </a:p>
+        </p:txBody>
+      </p:sp>
+      <p:sp>
+        <p:nvSpPr>
+          <p:cNvPr id="5" name="TextBox 4"/>
+          <p:cNvSpPr txBox="1"/>
+          <p:nvPr/>
+        </p:nvSpPr>
+        <p:spPr>
+          <a:xfrm>
+            <a:off x="731520" y="822960"/>
+            <a:ext cx="10698480" cy="685800"/>
+          </a:xfrm>
+          <a:prstGeom prst="rect">
+            <a:avLst/>
+          </a:prstGeom>
+          <a:noFill/>
+        </p:spPr>
+        <p:txBody>
+          <a:bodyPr wrap="none">
+            <a:spAutoFit/>
+          </a:bodyPr>
+          <a:lstStyle/>
+          <a:p>
+            <a:pPr>
+              <a:defRPr sz="2600" b="1">
+                <a:solidFill>
+                  <a:srgbClr val="065F46"/>
+                </a:solidFill>
+              </a:defRPr>
+            </a:pPr>
+            <a:r>
+              <a:t>GIS Outbreak Radar &amp; KVK Early Warning Network</a:t>
+            </a:r>
+          </a:p>
+        </p:txBody>
+      </p:sp>
+      <p:sp>
+        <p:nvSpPr>
+          <p:cNvPr id="6" name="TextBox 5"/>
+          <p:cNvSpPr txBox="1"/>
+          <p:nvPr/>
+        </p:nvSpPr>
+        <p:spPr>
+          <a:xfrm>
+            <a:off x="731520" y="1463040"/>
+            <a:ext cx="10698480" cy="411480"/>
+          </a:xfrm>
+          <a:prstGeom prst="rect">
+            <a:avLst/>
+          </a:prstGeom>
+          <a:noFill/>
+        </p:spPr>
+        <p:txBody>
+          <a:bodyPr wrap="none">
+            <a:spAutoFit/>
+          </a:bodyPr>
+          <a:lstStyle/>
+          <a:p>
+            <a:pPr>
+              <a:defRPr sz="1500" b="1">
+                <a:solidFill>
+                  <a:srgbClr val="0D9488"/>
+                </a:solidFill>
+              </a:defRPr>
+            </a:pPr>
+            <a:r>
+              <a:t>Epidemic Surveillance &amp; Proactive Outbreak Containment</a:t>
+            </a:r>
+          </a:p>
+        </p:txBody>
+      </p:sp>
+      <p:sp>
+        <p:nvSpPr>
+          <p:cNvPr id="7" name="Rounded Rectangle 6"/>
+          <p:cNvSpPr/>
+          <p:nvPr/>
+        </p:nvSpPr>
+        <p:spPr>
+          <a:xfrm>
+            <a:off x="731520" y="2011680"/>
+            <a:ext cx="5303520" cy="4206240"/>
+          </a:xfrm>
+          <a:prstGeom prst="roundRect">
+            <a:avLst/>
+          </a:prstGeom>
+          <a:solidFill>
+            <a:srgbClr val="F0FDF4"/>
+          </a:solidFill>
+          <a:ln w="19050">
+            <a:solidFill>
+              <a:srgbClr val="A7F3D0"/>
+            </a:solidFill>
+          </a:ln>
+        </p:spPr>
+        <p:style>
+          <a:lnRef idx="1">
+            <a:schemeClr val="accent1"/>
+          </a:lnRef>
+          <a:fillRef idx="3">
+            <a:schemeClr val="accent1"/>
+          </a:fillRef>
+          <a:effectRef idx="2">
+            <a:schemeClr val="accent1"/>
+          </a:effectRef>
+          <a:fontRef idx="minor">
+            <a:schemeClr val="lt1"/>
+          </a:fontRef>
+        </p:style>
+        <p:txBody>
+          <a:bodyPr rtlCol="0" anchor="ctr"/>
+          <a:lstStyle/>
+          <a:p>
+            <a:pPr algn="ctr"/>
+          </a:p>
+        </p:txBody>
+      </p:sp>
+      <p:sp>
+        <p:nvSpPr>
+          <p:cNvPr id="8" name="TextBox 7"/>
+          <p:cNvSpPr txBox="1"/>
+          <p:nvPr/>
+        </p:nvSpPr>
+        <p:spPr>
+          <a:xfrm>
             <a:off x="914400" y="2194560"/>
-            <a:ext cx="4937760" cy="3931920"/>
+            <a:ext cx="4937760" cy="3840480"/>
           </a:xfrm>
           <a:prstGeom prst="rect">
             <a:avLst/>
@@ -6399,79 +6786,79 @@
           <a:p>
             <a:pPr>
               <a:lnSpc>
-                <a:spcPct val="120000"/>
+                <a:spcPct val="125000"/>
               </a:lnSpc>
               <a:spcAft>
                 <a:spcPts val="1400"/>
               </a:spcAft>
               <a:defRPr sz="1400">
                 <a:solidFill>
-                  <a:srgbClr val="F3F4F6"/>
+                  <a:srgbClr val="1E293B"/>
                 </a:solidFill>
               </a:defRPr>
             </a:pPr>
             <a:r>
-              <a:t>• District Outbreak Heatmap: Real-time telemetry tracking pest/pathogen cases across Western Rajasthan.</a:t>
+              <a:t>✔  District Outbreak Heatmap: Real-time telemetry tracking pest/pathogen cases across Western Rajasthan.</a:t>
             </a:r>
           </a:p>
           <a:p>
             <a:pPr>
               <a:lnSpc>
-                <a:spcPct val="120000"/>
+                <a:spcPct val="125000"/>
               </a:lnSpc>
               <a:spcAft>
                 <a:spcPts val="1400"/>
               </a:spcAft>
               <a:defRPr sz="1400">
                 <a:solidFill>
-                  <a:srgbClr val="F3F4F6"/>
+                  <a:srgbClr val="1E293B"/>
                 </a:solidFill>
               </a:defRPr>
             </a:pPr>
             <a:r>
-              <a:t>• Proactive Radius Alerts: Sends SMS/Voice alerts when Lumpy Skin or Fungal Blight is detected within 15 km.</a:t>
+              <a:t>✔  Proactive Radius Alerts: Sends SMS/Voice alerts when Lumpy Skin or Fungal Blight is detected within 15 km.</a:t>
             </a:r>
           </a:p>
           <a:p>
             <a:pPr>
               <a:lnSpc>
-                <a:spcPct val="120000"/>
+                <a:spcPct val="125000"/>
               </a:lnSpc>
               <a:spcAft>
                 <a:spcPts val="1400"/>
               </a:spcAft>
               <a:defRPr sz="1400">
                 <a:solidFill>
-                  <a:srgbClr val="F3F4F6"/>
+                  <a:srgbClr val="1E293B"/>
                 </a:solidFill>
               </a:defRPr>
             </a:pPr>
             <a:r>
-              <a:t>• Prevents Local Spikes: Enables KVKs and animal husbandry departments to halt regional epidemics early.</a:t>
-            </a:r>
-          </a:p>
-        </p:txBody>
-      </p:sp>
-      <p:sp>
-        <p:nvSpPr>
-          <p:cNvPr id="8" name="Rounded Rectangle 7"/>
+              <a:t>✔  Prevents Local Spikes: Enables KVKs and animal husbandry departments to halt regional epidemics early.</a:t>
+            </a:r>
+          </a:p>
+        </p:txBody>
+      </p:sp>
+      <p:sp>
+        <p:nvSpPr>
+          <p:cNvPr id="9" name="Rounded Rectangle 8"/>
           <p:cNvSpPr/>
           <p:nvPr/>
         </p:nvSpPr>
         <p:spPr>
           <a:xfrm>
-            <a:off x="6263640" y="1965960"/>
-            <a:ext cx="5212080" cy="4389120"/>
+            <a:off x="6302959" y="1975104"/>
+            <a:ext cx="5193792" cy="4279392"/>
           </a:xfrm>
           <a:prstGeom prst="roundRect">
             <a:avLst/>
           </a:prstGeom>
           <a:solidFill>
-            <a:srgbClr val="111C34"/>
+            <a:srgbClr val="FFFFFF"/>
           </a:solidFill>
           <a:ln w="25400">
             <a:solidFill>
-              <a:srgbClr val="10B981"/>
+              <a:srgbClr val="A7F3D0"/>
             </a:solidFill>
           </a:ln>
         </p:spPr>
@@ -6499,7 +6886,7 @@
       </p:sp>
       <p:pic>
         <p:nvPicPr>
-          <p:cNvPr id="9" name="Picture 8" descr="advisory_alerts_1786640449172.png"/>
+          <p:cNvPr id="10" name="Picture 9" descr="advisory_alerts_1786640449172.png"/>
           <p:cNvPicPr>
             <a:picLocks noChangeAspect="1"/>
           </p:cNvPicPr>
@@ -6513,8 +6900,8 @@
         </p:blipFill>
         <p:spPr>
           <a:xfrm>
-            <a:off x="6309360" y="2011680"/>
-            <a:ext cx="5120640" cy="4297680"/>
+            <a:off x="6339535" y="2011680"/>
+            <a:ext cx="5120640" cy="4206240"/>
           </a:xfrm>
           <a:prstGeom prst="rect">
             <a:avLst/>
@@ -6523,13 +6910,13 @@
       </p:pic>
       <p:sp>
         <p:nvSpPr>
-          <p:cNvPr id="10" name="TextBox 9"/>
+          <p:cNvPr id="11" name="TextBox 10"/>
           <p:cNvSpPr txBox="1"/>
           <p:nvPr/>
         </p:nvSpPr>
         <p:spPr>
           <a:xfrm>
-            <a:off x="731520" y="6400800"/>
+            <a:off x="731520" y="6355080"/>
             <a:ext cx="10698480" cy="274320"/>
           </a:xfrm>
           <a:prstGeom prst="rect">
@@ -6546,12 +6933,12 @@
             <a:pPr>
               <a:defRPr sz="1000">
                 <a:solidFill>
-                  <a:srgbClr val="9CA3AF"/>
+                  <a:srgbClr val="64748B"/>
                 </a:solidFill>
               </a:defRPr>
             </a:pPr>
             <a:r>
-              <a:t>AgriVision AI Platform | SIH 2026 Internal Hackathon | IIT Jodhpur &amp; AIIMS Jodhpur</a:t>
+              <a:t>AgriVision AI Platform  •  SIH 2026 Internal Hackathon  •  IIT Jodhpur &amp; AIIMS Jodhpur</a:t>
             </a:r>
           </a:p>
         </p:txBody>
@@ -6589,7 +6976,7 @@
             <a:avLst/>
           </a:prstGeom>
           <a:solidFill>
-            <a:srgbClr val="0B1426"/>
+            <a:srgbClr val="F8FAFC"/>
           </a:solidFill>
           <a:ln>
             <a:noFill/>
@@ -6619,130 +7006,23 @@
       </p:sp>
       <p:sp>
         <p:nvSpPr>
-          <p:cNvPr id="3" name="TextBox 2"/>
-          <p:cNvSpPr txBox="1"/>
-          <p:nvPr/>
-        </p:nvSpPr>
-        <p:spPr>
-          <a:xfrm>
-            <a:off x="731520" y="457200"/>
-            <a:ext cx="10698480" cy="365760"/>
-          </a:xfrm>
-          <a:prstGeom prst="rect">
-            <a:avLst/>
-          </a:prstGeom>
-          <a:noFill/>
-        </p:spPr>
-        <p:txBody>
-          <a:bodyPr wrap="none">
-            <a:spAutoFit/>
-          </a:bodyPr>
-          <a:lstStyle/>
-          <a:p>
-            <a:pPr>
-              <a:defRPr sz="1100" b="1">
-                <a:solidFill>
-                  <a:srgbClr val="10B981"/>
-                </a:solidFill>
-              </a:defRPr>
-            </a:pPr>
-            <a:r>
-              <a:t>SLIDE 9 | PRODUCTION STACK &amp; DEPLOYMENT</a:t>
-            </a:r>
-          </a:p>
-        </p:txBody>
-      </p:sp>
-      <p:sp>
-        <p:nvSpPr>
-          <p:cNvPr id="4" name="TextBox 3"/>
-          <p:cNvSpPr txBox="1"/>
-          <p:nvPr/>
-        </p:nvSpPr>
-        <p:spPr>
-          <a:xfrm>
-            <a:off x="731520" y="777240"/>
-            <a:ext cx="10698480" cy="731520"/>
-          </a:xfrm>
-          <a:prstGeom prst="rect">
-            <a:avLst/>
-          </a:prstGeom>
-          <a:noFill/>
-        </p:spPr>
-        <p:txBody>
-          <a:bodyPr wrap="none">
-            <a:spAutoFit/>
-          </a:bodyPr>
-          <a:lstStyle/>
-          <a:p>
-            <a:pPr>
-              <a:defRPr sz="2600" b="1">
-                <a:solidFill>
-                  <a:srgbClr val="FFFFFF"/>
-                </a:solidFill>
-              </a:defRPr>
-            </a:pPr>
-            <a:r>
-              <a:t>Live Production Stack &amp; Deployment Model</a:t>
-            </a:r>
-          </a:p>
-        </p:txBody>
-      </p:sp>
-      <p:sp>
-        <p:nvSpPr>
-          <p:cNvPr id="5" name="TextBox 4"/>
-          <p:cNvSpPr txBox="1"/>
-          <p:nvPr/>
-        </p:nvSpPr>
-        <p:spPr>
-          <a:xfrm>
-            <a:off x="731520" y="1371600"/>
-            <a:ext cx="10698480" cy="457200"/>
-          </a:xfrm>
-          <a:prstGeom prst="rect">
-            <a:avLst/>
-          </a:prstGeom>
-          <a:noFill/>
-        </p:spPr>
-        <p:txBody>
-          <a:bodyPr wrap="none">
-            <a:spAutoFit/>
-          </a:bodyPr>
-          <a:lstStyle/>
-          <a:p>
-            <a:pPr>
-              <a:defRPr sz="1500" b="1">
-                <a:solidFill>
-                  <a:srgbClr val="34D399"/>
-                </a:solidFill>
-              </a:defRPr>
-            </a:pPr>
-            <a:r>
-              <a:t>Fully Built, Tested &amp; Deployed Today</a:t>
-            </a:r>
-          </a:p>
-        </p:txBody>
-      </p:sp>
-      <p:sp>
-        <p:nvSpPr>
-          <p:cNvPr id="6" name="Rounded Rectangle 5"/>
+          <p:cNvPr id="3" name="Rectangle 2"/>
           <p:cNvSpPr/>
           <p:nvPr/>
         </p:nvSpPr>
         <p:spPr>
           <a:xfrm>
-            <a:off x="731520" y="2011680"/>
-            <a:ext cx="5303520" cy="4297680"/>
-          </a:xfrm>
-          <a:prstGeom prst="roundRect">
+            <a:off x="731520" y="365760"/>
+            <a:ext cx="10728655" cy="54864"/>
+          </a:xfrm>
+          <a:prstGeom prst="rect">
             <a:avLst/>
           </a:prstGeom>
           <a:solidFill>
-            <a:srgbClr val="111C34"/>
+            <a:srgbClr val="047857"/>
           </a:solidFill>
-          <a:ln w="19050">
-            <a:solidFill>
-              <a:srgbClr val="10B981"/>
-            </a:solidFill>
+          <a:ln>
+            <a:noFill/>
           </a:ln>
         </p:spPr>
         <p:style>
@@ -6769,14 +7049,164 @@
       </p:sp>
       <p:sp>
         <p:nvSpPr>
-          <p:cNvPr id="7" name="TextBox 6"/>
+          <p:cNvPr id="4" name="TextBox 3"/>
           <p:cNvSpPr txBox="1"/>
           <p:nvPr/>
         </p:nvSpPr>
         <p:spPr>
           <a:xfrm>
+            <a:off x="731520" y="502920"/>
+            <a:ext cx="10698480" cy="320040"/>
+          </a:xfrm>
+          <a:prstGeom prst="rect">
+            <a:avLst/>
+          </a:prstGeom>
+          <a:noFill/>
+        </p:spPr>
+        <p:txBody>
+          <a:bodyPr wrap="none">
+            <a:spAutoFit/>
+          </a:bodyPr>
+          <a:lstStyle/>
+          <a:p>
+            <a:pPr>
+              <a:defRPr sz="1100" b="1">
+                <a:solidFill>
+                  <a:srgbClr val="047857"/>
+                </a:solidFill>
+              </a:defRPr>
+            </a:pPr>
+            <a:r>
+              <a:t>SLIDE 9  |  PRODUCTION STACK &amp; DEPLOYMENT</a:t>
+            </a:r>
+          </a:p>
+        </p:txBody>
+      </p:sp>
+      <p:sp>
+        <p:nvSpPr>
+          <p:cNvPr id="5" name="TextBox 4"/>
+          <p:cNvSpPr txBox="1"/>
+          <p:nvPr/>
+        </p:nvSpPr>
+        <p:spPr>
+          <a:xfrm>
+            <a:off x="731520" y="822960"/>
+            <a:ext cx="10698480" cy="685800"/>
+          </a:xfrm>
+          <a:prstGeom prst="rect">
+            <a:avLst/>
+          </a:prstGeom>
+          <a:noFill/>
+        </p:spPr>
+        <p:txBody>
+          <a:bodyPr wrap="none">
+            <a:spAutoFit/>
+          </a:bodyPr>
+          <a:lstStyle/>
+          <a:p>
+            <a:pPr>
+              <a:defRPr sz="2600" b="1">
+                <a:solidFill>
+                  <a:srgbClr val="065F46"/>
+                </a:solidFill>
+              </a:defRPr>
+            </a:pPr>
+            <a:r>
+              <a:t>Live Production Stack &amp; Deployment Model</a:t>
+            </a:r>
+          </a:p>
+        </p:txBody>
+      </p:sp>
+      <p:sp>
+        <p:nvSpPr>
+          <p:cNvPr id="6" name="TextBox 5"/>
+          <p:cNvSpPr txBox="1"/>
+          <p:nvPr/>
+        </p:nvSpPr>
+        <p:spPr>
+          <a:xfrm>
+            <a:off x="731520" y="1463040"/>
+            <a:ext cx="10698480" cy="411480"/>
+          </a:xfrm>
+          <a:prstGeom prst="rect">
+            <a:avLst/>
+          </a:prstGeom>
+          <a:noFill/>
+        </p:spPr>
+        <p:txBody>
+          <a:bodyPr wrap="none">
+            <a:spAutoFit/>
+          </a:bodyPr>
+          <a:lstStyle/>
+          <a:p>
+            <a:pPr>
+              <a:defRPr sz="1500" b="1">
+                <a:solidFill>
+                  <a:srgbClr val="0D9488"/>
+                </a:solidFill>
+              </a:defRPr>
+            </a:pPr>
+            <a:r>
+              <a:t>Fully Built, Tested &amp; Deployed Today</a:t>
+            </a:r>
+          </a:p>
+        </p:txBody>
+      </p:sp>
+      <p:sp>
+        <p:nvSpPr>
+          <p:cNvPr id="7" name="Rounded Rectangle 6"/>
+          <p:cNvSpPr/>
+          <p:nvPr/>
+        </p:nvSpPr>
+        <p:spPr>
+          <a:xfrm>
+            <a:off x="731520" y="2011680"/>
+            <a:ext cx="5303520" cy="4206240"/>
+          </a:xfrm>
+          <a:prstGeom prst="roundRect">
+            <a:avLst/>
+          </a:prstGeom>
+          <a:solidFill>
+            <a:srgbClr val="F0FDF4"/>
+          </a:solidFill>
+          <a:ln w="19050">
+            <a:solidFill>
+              <a:srgbClr val="A7F3D0"/>
+            </a:solidFill>
+          </a:ln>
+        </p:spPr>
+        <p:style>
+          <a:lnRef idx="1">
+            <a:schemeClr val="accent1"/>
+          </a:lnRef>
+          <a:fillRef idx="3">
+            <a:schemeClr val="accent1"/>
+          </a:fillRef>
+          <a:effectRef idx="2">
+            <a:schemeClr val="accent1"/>
+          </a:effectRef>
+          <a:fontRef idx="minor">
+            <a:schemeClr val="lt1"/>
+          </a:fontRef>
+        </p:style>
+        <p:txBody>
+          <a:bodyPr rtlCol="0" anchor="ctr"/>
+          <a:lstStyle/>
+          <a:p>
+            <a:pPr algn="ctr"/>
+          </a:p>
+        </p:txBody>
+      </p:sp>
+      <p:sp>
+        <p:nvSpPr>
+          <p:cNvPr id="8" name="TextBox 7"/>
+          <p:cNvSpPr txBox="1"/>
+          <p:nvPr/>
+        </p:nvSpPr>
+        <p:spPr>
+          <a:xfrm>
             <a:off x="914400" y="2194560"/>
-            <a:ext cx="4937760" cy="3931920"/>
+            <a:ext cx="4937760" cy="3840480"/>
           </a:xfrm>
           <a:prstGeom prst="rect">
             <a:avLst/>
@@ -6791,79 +7221,79 @@
           <a:p>
             <a:pPr>
               <a:lnSpc>
-                <a:spcPct val="120000"/>
+                <a:spcPct val="125000"/>
               </a:lnSpc>
               <a:spcAft>
                 <a:spcPts val="1400"/>
               </a:spcAft>
               <a:defRPr sz="1400">
                 <a:solidFill>
-                  <a:srgbClr val="F3F4F6"/>
+                  <a:srgbClr val="1E293B"/>
                 </a:solidFill>
               </a:defRPr>
             </a:pPr>
             <a:r>
-              <a:t>• Production Stack: React 18, Vite, Vanilla CSS, Lucide Icons, Canvas API, WebRTC MediaDevices.</a:t>
+              <a:t>✔  Production Stack: React 18, Vite, Vanilla CSS, Lucide Icons, Canvas API, WebRTC MediaDevices.</a:t>
             </a:r>
           </a:p>
           <a:p>
             <a:pPr>
               <a:lnSpc>
-                <a:spcPct val="120000"/>
+                <a:spcPct val="125000"/>
               </a:lnSpc>
               <a:spcAft>
                 <a:spcPts val="1400"/>
               </a:spcAft>
               <a:defRPr sz="1400">
                 <a:solidFill>
-                  <a:srgbClr val="F3F4F6"/>
+                  <a:srgbClr val="1E293B"/>
                 </a:solidFill>
               </a:defRPr>
             </a:pPr>
             <a:r>
-              <a:t>• AI Services: Multimodal Neural Vision Model API + Local Edge Diagnostics Engine.</a:t>
+              <a:t>✔  AI Services: Multimodal Neural Vision Model API + Local Edge Diagnostics Engine.</a:t>
             </a:r>
           </a:p>
           <a:p>
             <a:pPr>
               <a:lnSpc>
-                <a:spcPct val="120000"/>
+                <a:spcPct val="125000"/>
               </a:lnSpc>
               <a:spcAft>
                 <a:spcPts val="1400"/>
               </a:spcAft>
               <a:defRPr sz="1400">
                 <a:solidFill>
-                  <a:srgbClr val="F3F4F6"/>
+                  <a:srgbClr val="1E293B"/>
                 </a:solidFill>
               </a:defRPr>
             </a:pPr>
             <a:r>
-              <a:t>• Live Deployment: Hosted live on Vercel with automatic GitHub CI/CD integration.</a:t>
-            </a:r>
-          </a:p>
-        </p:txBody>
-      </p:sp>
-      <p:sp>
-        <p:nvSpPr>
-          <p:cNvPr id="8" name="Rounded Rectangle 7"/>
+              <a:t>✔  Live Deployment: Hosted live on Vercel with automatic GitHub CI/CD integration.</a:t>
+            </a:r>
+          </a:p>
+        </p:txBody>
+      </p:sp>
+      <p:sp>
+        <p:nvSpPr>
+          <p:cNvPr id="9" name="Rounded Rectangle 8"/>
           <p:cNvSpPr/>
           <p:nvPr/>
         </p:nvSpPr>
         <p:spPr>
           <a:xfrm>
-            <a:off x="6263640" y="1965960"/>
-            <a:ext cx="5212080" cy="4389120"/>
+            <a:off x="6302959" y="1975104"/>
+            <a:ext cx="5193792" cy="4279392"/>
           </a:xfrm>
           <a:prstGeom prst="roundRect">
             <a:avLst/>
           </a:prstGeom>
           <a:solidFill>
-            <a:srgbClr val="111C34"/>
+            <a:srgbClr val="FFFFFF"/>
           </a:solidFill>
           <a:ln w="25400">
             <a:solidFill>
-              <a:srgbClr val="10B981"/>
+              <a:srgbClr val="A7F3D0"/>
             </a:solidFill>
           </a:ln>
         </p:spPr>
@@ -6891,7 +7321,7 @@
       </p:sp>
       <p:pic>
         <p:nvPicPr>
-          <p:cNvPr id="9" name="Picture 8" descr="farm_ledger_1786640439309.png"/>
+          <p:cNvPr id="10" name="Picture 9" descr="farm_ledger_1786640439309.png"/>
           <p:cNvPicPr>
             <a:picLocks noChangeAspect="1"/>
           </p:cNvPicPr>
@@ -6905,8 +7335,8 @@
         </p:blipFill>
         <p:spPr>
           <a:xfrm>
-            <a:off x="6309360" y="2011680"/>
-            <a:ext cx="5120640" cy="4297680"/>
+            <a:off x="6339535" y="2011680"/>
+            <a:ext cx="5120640" cy="4206240"/>
           </a:xfrm>
           <a:prstGeom prst="rect">
             <a:avLst/>
@@ -6915,13 +7345,13 @@
       </p:pic>
       <p:sp>
         <p:nvSpPr>
-          <p:cNvPr id="10" name="TextBox 9"/>
+          <p:cNvPr id="11" name="TextBox 10"/>
           <p:cNvSpPr txBox="1"/>
           <p:nvPr/>
         </p:nvSpPr>
         <p:spPr>
           <a:xfrm>
-            <a:off x="731520" y="6400800"/>
+            <a:off x="731520" y="6355080"/>
             <a:ext cx="10698480" cy="274320"/>
           </a:xfrm>
           <a:prstGeom prst="rect">
@@ -6938,12 +7368,12 @@
             <a:pPr>
               <a:defRPr sz="1000">
                 <a:solidFill>
-                  <a:srgbClr val="9CA3AF"/>
+                  <a:srgbClr val="64748B"/>
                 </a:solidFill>
               </a:defRPr>
             </a:pPr>
             <a:r>
-              <a:t>AgriVision AI Platform | SIH 2026 Internal Hackathon | IIT Jodhpur &amp; AIIMS Jodhpur</a:t>
+              <a:t>AgriVision AI Platform  •  SIH 2026 Internal Hackathon  •  IIT Jodhpur &amp; AIIMS Jodhpur</a:t>
             </a:r>
           </a:p>
         </p:txBody>

</xml_diff>